<commit_message>
Rework internship deck tone: warmer, humble, no em dashes
Softened the deck from a hard-sell to a warm, professional, humble tone.
Updated the hours-saved model to include the manually-updated daily report
tab (~275-445 hrs/yr, ~7-11 work-weeks). Replaced the 'Why Me' closer with
a genuine thank-you that expresses gratitude and interest in returning
post-graduation. Removed em dashes from all visible slide text.
</commit_message>
<xml_diff>
--- a/docs/AMKAD_Internship_Presentation.pptx
+++ b/docs/AMKAD_Internship_Presentation.pptx
@@ -3410,7 +3410,7 @@
                 </a:solidFill>
                 <a:latin typeface="Calibri"/>
               </a:rPr>
-              <a:t>From manual, invisible processes to a live dashboard and self-running data pipelines</a:t>
+              <a:t>Moving a few manual processes toward a live dashboard and pipelines that run on their own</a:t>
             </a:r>
           </a:p>
         </p:txBody>
@@ -3649,7 +3649,7 @@
                 </a:solidFill>
                 <a:latin typeface="Calibri"/>
               </a:rPr>
-              <a:t>What it actually took — and what I learned</a:t>
+              <a:t>What it took along the way, and what I learned</a:t>
             </a:r>
           </a:p>
         </p:txBody>
@@ -4051,7 +4051,7 @@
                 </a:solidFill>
                 <a:latin typeface="Calibri"/>
               </a:rPr>
-              <a:t>•  Landed on GitHub Actions — zero-friction, no cost</a:t>
+              <a:t>•  Landed on GitHub Actions, which worked cleanly and at no cost</a:t>
             </a:r>
           </a:p>
         </p:txBody>
@@ -6198,7 +6198,7 @@
                 </a:solidFill>
                 <a:latin typeface="Calibri"/>
               </a:rPr>
-              <a:t>•  Expand the SOA framework to the remaining customers and countries — the reusable engine is already built.</a:t>
+              <a:t>•  Extend the SOA framework to more customers and countries, since the reusable engine is already in place.</a:t>
             </a:r>
           </a:p>
           <a:p>
@@ -6214,7 +6214,7 @@
                 </a:solidFill>
                 <a:latin typeface="Calibri"/>
               </a:rPr>
-              <a:t>•  Migrate the data layer to a centralized database (SQL / Data Factory) — the scalable backbone for everything above.</a:t>
+              <a:t>•  Move the data layer toward a centralized database (SQL and Data Factory), which would be a stronger backbone for everything above.</a:t>
             </a:r>
           </a:p>
           <a:p>
@@ -6230,7 +6230,7 @@
                 </a:solidFill>
                 <a:latin typeface="Calibri"/>
               </a:rPr>
-              <a:t>•  Publish leadership-facing Power BI dashboards on top of the same consolidated data.</a:t>
+              <a:t>•  Build leadership-facing Power BI dashboards on top of the same consolidated data.</a:t>
             </a:r>
           </a:p>
           <a:p>
@@ -6246,7 +6246,7 @@
                 </a:solidFill>
                 <a:latin typeface="Calibri"/>
               </a:rPr>
-              <a:t>•  Hardening: standardize the monthly folder naming and add optional alerting for missing / late source files.</a:t>
+              <a:t>•  Small hardening steps, like standardizing the monthly folder names and adding alerts for missing or late source files.</a:t>
             </a:r>
           </a:p>
         </p:txBody>
@@ -6513,7 +6513,7 @@
                 </a:solidFill>
                 <a:latin typeface="Calibri"/>
               </a:rPr>
-              <a:t>WHY ME</a:t>
+              <a:t>LOOKING AHEAD</a:t>
             </a:r>
           </a:p>
         </p:txBody>
@@ -6552,7 +6552,7 @@
                 </a:solidFill>
                 <a:latin typeface="Calibri"/>
               </a:rPr>
-              <a:t>I don't just spot automation opportunities — I ship them.</a:t>
+              <a:t>I have genuinely loved being part of this team.</a:t>
             </a:r>
           </a:p>
         </p:txBody>
@@ -6591,7 +6591,7 @@
                 </a:solidFill>
                 <a:latin typeface="Calibri"/>
               </a:rPr>
-              <a:t>•  Built net-new capability that didn't exist — and put it into production.</a:t>
+              <a:t>•  Thank you for the trust, the patience, and the chance to work on real problems that matter to the team.</a:t>
             </a:r>
           </a:p>
           <a:p>
@@ -6607,7 +6607,7 @@
                 </a:solidFill>
                 <a:latin typeface="Calibri"/>
               </a:rPr>
-              <a:t>•  Delivered quantifiable time back to the team (~210–360 hrs/yr) and cut real error &amp; key-person risk.</a:t>
+              <a:t>•  I learned an enormous amount here, from the AR and collections side of the business to the tools that support it.</a:t>
             </a:r>
           </a:p>
           <a:p>
@@ -6623,7 +6623,7 @@
                 </a:solidFill>
                 <a:latin typeface="Calibri"/>
               </a:rPr>
-              <a:t>•  Worked through ambiguity, a hosting blocker, a production incident, and dozens of technical dead-ends — and still shipped.</a:t>
+              <a:t>•  I am proud of what we built together, and I know there is more I could contribute with more time.</a:t>
             </a:r>
           </a:p>
           <a:p>
@@ -6639,7 +6639,7 @@
                 </a:solidFill>
                 <a:latin typeface="Calibri"/>
               </a:rPr>
-              <a:t>•  Left everything documented, tested, and running without me.</a:t>
+              <a:t>•  If the opportunity is there after I graduate, I would love to come back and keep building on this with you.</a:t>
             </a:r>
           </a:p>
         </p:txBody>
@@ -6724,7 +6724,7 @@
                 </a:solidFill>
                 <a:latin typeface="Calibri"/>
               </a:rPr>
-              <a:t>Give me the next problem — I'll ship the solution.</a:t>
+              <a:t>Thank you for a great experience. I hope this is the start, not the end.</a:t>
             </a:r>
           </a:p>
         </p:txBody>
@@ -6924,7 +6924,7 @@
                 </a:solidFill>
                 <a:latin typeface="Calibri"/>
               </a:rPr>
-              <a:t>Finance Intern, Controlling  ·  DHL Express Americas — Key Account Desk (AMKAD)</a:t>
+              <a:t>Finance Intern, Controlling  ·  DHL Express Americas, Key Account Desk (AMKAD)</a:t>
             </a:r>
           </a:p>
           <a:p>
@@ -6940,7 +6940,7 @@
                 </a:solidFill>
                 <a:latin typeface="Calibri"/>
               </a:rPr>
-              <a:t>Questions welcome.</a:t>
+              <a:t>I would be happy to answer any questions.</a:t>
             </a:r>
           </a:p>
         </p:txBody>
@@ -7129,7 +7129,7 @@
                 </a:solidFill>
                 <a:latin typeface="Calibri"/>
               </a:rPr>
-              <a:t>THE BOTTOM LINE</a:t>
+              <a:t>THE IMPACT</a:t>
             </a:r>
           </a:p>
         </p:txBody>
@@ -7212,7 +7212,7 @@
                 </a:solidFill>
                 <a:latin typeface="Calibri"/>
               </a:rPr>
-              <a:t>What this internship delivered</a:t>
+              <a:t>What the work added up to</a:t>
             </a:r>
           </a:p>
         </p:txBody>
@@ -7387,7 +7387,7 @@
                 </a:solidFill>
                 <a:latin typeface="Calibri"/>
               </a:rPr>
-              <a:t>~210 hrs</a:t>
+              <a:t>~275 hrs</a:t>
             </a:r>
           </a:p>
           <a:p>
@@ -7403,7 +7403,7 @@
                 </a:solidFill>
                 <a:latin typeface="Calibri"/>
               </a:rPr>
-              <a:t>Collector time recovered per year (conservative) — up to ~360 hrs</a:t>
+              <a:t>of team time given back each year, and likely more. A conservative estimate.</a:t>
             </a:r>
           </a:p>
         </p:txBody>
@@ -7550,7 +7550,7 @@
                 </a:solidFill>
                 <a:latin typeface="Calibri"/>
               </a:rPr>
-              <a:t>Recurring SOAs generated &amp; emailed automatically (Arrow ×5, Baker ×1)</a:t>
+              <a:t>statements now generated and emailed automatically (Arrow ×5, Baker ×1)</a:t>
             </a:r>
           </a:p>
         </p:txBody>
@@ -7697,7 +7697,7 @@
                 </a:solidFill>
                 <a:latin typeface="Calibri"/>
               </a:rPr>
-              <a:t>Live AR reporting capability that did not exist before</a:t>
+              <a:t>shared AR reporting view the team did not have in one place before</a:t>
             </a:r>
           </a:p>
         </p:txBody>
@@ -7730,13 +7730,13 @@
               </a:spcAft>
             </a:pPr>
             <a:r>
-              <a:rPr sz="1800" b="1" i="0">
+              <a:rPr sz="1700" b="1" i="0">
                 <a:solidFill>
                   <a:srgbClr val="A5040D"/>
                 </a:solidFill>
                 <a:latin typeface="Calibri"/>
               </a:rPr>
-              <a:t>≈ 5 to 9 full 40-hour work-weeks of collector time returned to actual collections — every year.</a:t>
+              <a:t>That is roughly 7 to 11 full work-weeks a year that collectors can spend on collections instead of manual reporting.</a:t>
             </a:r>
           </a:p>
         </p:txBody>
@@ -7775,7 +7775,7 @@
                 </a:solidFill>
                 <a:latin typeface="Calibri"/>
               </a:rPr>
-              <a:t>•  Built net-new AR visibility (aging, UAC, trends, what-if simulators) that leadership never had before.</a:t>
+              <a:t>•  Helped bring AR visibility together in one place: aging, UAC, trends, and what-if scenarios.</a:t>
             </a:r>
           </a:p>
           <a:p>
@@ -7791,7 +7791,7 @@
                 </a:solidFill>
                 <a:latin typeface="Calibri"/>
               </a:rPr>
-              <a:t>•  Automated the daily data file that feeds it — no one has to rebuild it by hand anymore.</a:t>
+              <a:t>•  Took the daily data file off someone's plate so it no longer has to be rebuilt by hand.</a:t>
             </a:r>
           </a:p>
           <a:p>
@@ -7807,7 +7807,7 @@
                 </a:solidFill>
                 <a:latin typeface="Calibri"/>
               </a:rPr>
-              <a:t>•  Removed a single-person dependency and the error risk that came with manual copy/paste.</a:t>
+              <a:t>•  Reduced the reliance on one person, and the small errors that manual copy and paste can introduce.</a:t>
             </a:r>
           </a:p>
         </p:txBody>
@@ -8221,7 +8221,7 @@
                 </a:solidFill>
                 <a:latin typeface="Calibri"/>
               </a:rPr>
-              <a:t>The manual, invisible starting point</a:t>
+              <a:t>The manual starting point</a:t>
             </a:r>
           </a:p>
         </p:txBody>
@@ -8313,7 +8313,7 @@
                 </a:solidFill>
                 <a:latin typeface="Calibri"/>
               </a:rPr>
-              <a:t>What I built</a:t>
+              <a:t>What I worked on</a:t>
             </a:r>
           </a:p>
           <a:p>
@@ -8437,7 +8437,7 @@
                 </a:solidFill>
                 <a:latin typeface="Calibri"/>
               </a:rPr>
-              <a:t>Hours saved — with the math shown</a:t>
+              <a:t>Time saved, with the math shown</a:t>
             </a:r>
           </a:p>
         </p:txBody>
@@ -8545,7 +8545,7 @@
                 </a:solidFill>
                 <a:latin typeface="Calibri"/>
               </a:rPr>
-              <a:t>Power BI, data, and production challenges</a:t>
+              <a:t>Power BI, data, and the challenges along the way</a:t>
             </a:r>
           </a:p>
         </p:txBody>
@@ -8653,7 +8653,7 @@
                 </a:solidFill>
                 <a:latin typeface="Calibri"/>
               </a:rPr>
-              <a:t>How this scales beyond me</a:t>
+              <a:t>How this can grow from here</a:t>
             </a:r>
           </a:p>
         </p:txBody>
@@ -9317,7 +9317,7 @@
                 </a:solidFill>
                 <a:latin typeface="Calibri"/>
               </a:rPr>
-              <a:t>•  Copy → paste → calculate → save-as, by hand</a:t>
+              <a:t>•  Copy, paste, calculate, and save a new file</a:t>
             </a:r>
           </a:p>
           <a:p>
@@ -9333,7 +9333,7 @@
                 </a:solidFill>
                 <a:latin typeface="Calibri"/>
               </a:rPr>
-              <a:t>•  ~15 min/day, and only one person knew the steps</a:t>
+              <a:t>•  Around 30 to 35 min a day, and mostly one person</a:t>
             </a:r>
           </a:p>
           <a:p>
@@ -9349,7 +9349,7 @@
                 </a:solidFill>
                 <a:latin typeface="Calibri"/>
               </a:rPr>
-              <a:t>•  Manual copy/paste → real error risk</a:t>
+              <a:t>•  Manual copy and paste can introduce small errors</a:t>
             </a:r>
           </a:p>
         </p:txBody>
@@ -9723,7 +9723,7 @@
                 </a:solidFill>
                 <a:latin typeface="Calibri"/>
               </a:rPr>
-              <a:t>WHAT I BUILT</a:t>
+              <a:t>WHAT I WORKED ON</a:t>
             </a:r>
           </a:p>
         </p:txBody>
@@ -9806,7 +9806,7 @@
                 </a:solidFill>
                 <a:latin typeface="Calibri"/>
               </a:rPr>
-              <a:t>Three connected automations — one AR workflow, digitized</a:t>
+              <a:t>Three connected automations across the AR workflow</a:t>
             </a:r>
           </a:p>
         </p:txBody>
@@ -10029,7 +10029,7 @@
                 </a:solidFill>
                 <a:latin typeface="Calibri"/>
               </a:rPr>
-              <a:t>•  Drill-downs + what-if payment simulators</a:t>
+              <a:t>•  Drill-downs and what-if payment simulators</a:t>
             </a:r>
           </a:p>
           <a:p>
@@ -10045,7 +10045,7 @@
                 </a:solidFill>
                 <a:latin typeface="Calibri"/>
               </a:rPr>
-              <a:t>•  New visibility that didn't exist before</a:t>
+              <a:t>•  Visibility we did not have in one place</a:t>
             </a:r>
           </a:p>
         </p:txBody>
@@ -10208,7 +10208,7 @@
                 </a:solidFill>
                 <a:latin typeface="Calibri"/>
               </a:rPr>
-              <a:t>•  Source file lands → data extracted &amp; appended</a:t>
+              <a:t>•  Source file lands, data is extracted and added</a:t>
             </a:r>
           </a:p>
           <a:p>
@@ -10240,7 +10240,7 @@
                 </a:solidFill>
                 <a:latin typeface="Calibri"/>
               </a:rPr>
-              <a:t>•  Runs hands-off, every business day</a:t>
+              <a:t>•  Runs on its own, every business day</a:t>
             </a:r>
           </a:p>
         </p:txBody>
@@ -10387,7 +10387,7 @@
                 </a:solidFill>
                 <a:latin typeface="Calibri"/>
               </a:rPr>
-              <a:t>•  6 weekly statements auto-generated</a:t>
+              <a:t>•  6 weekly statements generated automatically</a:t>
             </a:r>
           </a:p>
           <a:p>
@@ -10403,7 +10403,7 @@
                 </a:solidFill>
                 <a:latin typeface="Calibri"/>
               </a:rPr>
-              <a:t>•  Auto-emailed with attachments &amp; CCs</a:t>
+              <a:t>•  Emailed with attachments and stakeholders CC'd</a:t>
             </a:r>
           </a:p>
           <a:p>
@@ -10419,7 +10419,7 @@
                 </a:solidFill>
                 <a:latin typeface="Calibri"/>
               </a:rPr>
-              <a:t>•  Configurable framework, not one-offs</a:t>
+              <a:t>•  A configurable framework, not one-offs</a:t>
             </a:r>
           </a:p>
           <a:p>
@@ -10435,7 +10435,7 @@
                 </a:solidFill>
                 <a:latin typeface="Calibri"/>
               </a:rPr>
-              <a:t>•  Collectors handle exceptions only</a:t>
+              <a:t>•  Collectors step in only for exceptions</a:t>
             </a:r>
           </a:p>
         </p:txBody>
@@ -10697,7 +10697,7 @@
                 </a:solidFill>
                 <a:latin typeface="Calibri"/>
               </a:rPr>
-              <a:t>A live view of the receivables book — built from nothing</a:t>
+              <a:t>A live view of the receivables book that we did not have before</a:t>
             </a:r>
           </a:p>
         </p:txBody>
@@ -10780,7 +10780,7 @@
                 </a:solidFill>
                 <a:latin typeface="Calibri"/>
               </a:rPr>
-              <a:t>•  Portfolio KPIs: Total AR, Overdue %, GT60 / GT90 aging, UAC, gross sales, payments.</a:t>
+              <a:t>•  Portfolio KPIs: Total AR, Overdue %, GT60 and GT90 aging, UAC, gross sales, payments.</a:t>
             </a:r>
           </a:p>
           <a:p>
@@ -10796,7 +10796,7 @@
                 </a:solidFill>
                 <a:latin typeface="Calibri"/>
               </a:rPr>
-              <a:t>•  Drill-downs both ways — country ↔ customer — to see what's driving every number.</a:t>
+              <a:t>•  Drill-downs both ways, from country to customer, to see what is driving each number.</a:t>
             </a:r>
           </a:p>
           <a:p>
@@ -10828,7 +10828,7 @@
                 </a:solidFill>
                 <a:latin typeface="Calibri"/>
               </a:rPr>
-              <a:t>•  What-if payment simulators: portfolio-level and customer-level, with manual allocation across aging bands and UAC.</a:t>
+              <a:t>•  What-if payment simulators, at portfolio and customer level, with manual allocation across aging bands and UAC.</a:t>
             </a:r>
           </a:p>
           <a:p>
@@ -10844,7 +10844,7 @@
                 </a:solidFill>
                 <a:latin typeface="Calibri"/>
               </a:rPr>
-              <a:t>•  Editable risk thresholds and an Action-Required list mapped to the collections escalation process.</a:t>
+              <a:t>•  Editable risk thresholds and an Action-Required list that follows the collections escalation process.</a:t>
             </a:r>
           </a:p>
         </p:txBody>
@@ -10931,7 +10931,7 @@
                 </a:solidFill>
                 <a:latin typeface="Calibri"/>
               </a:rPr>
-              <a:t>Why it matters:  this reporting did not exist before — I created the visibility, not just automated an existing report.</a:t>
+              <a:t>It replaced the report tab that used to be updated by hand each day, and brought AR visibility together in one place that the team did not have before.</a:t>
             </a:r>
           </a:p>
         </p:txBody>
@@ -11276,7 +11276,7 @@
                 </a:solidFill>
                 <a:latin typeface="Calibri"/>
               </a:rPr>
-              <a:t>BEFORE  —  ~15 min/day, one person</a:t>
+              <a:t>Before:  around 30 to 35 min a day, by hand</a:t>
             </a:r>
           </a:p>
         </p:txBody>
@@ -11315,7 +11315,7 @@
                 </a:solidFill>
                 <a:latin typeface="Calibri"/>
               </a:rPr>
-              <a:t>•  Open the emailed report, copy the data</a:t>
+              <a:t>•  Open the emailed report and copy the data</a:t>
             </a:r>
           </a:p>
           <a:p>
@@ -11331,7 +11331,7 @@
                 </a:solidFill>
                 <a:latin typeface="Calibri"/>
               </a:rPr>
-              <a:t>•  Paste into a template, calculate</a:t>
+              <a:t>•  Paste into a template and calculate</a:t>
             </a:r>
           </a:p>
           <a:p>
@@ -11363,7 +11363,7 @@
                 </a:solidFill>
                 <a:latin typeface="Calibri"/>
               </a:rPr>
-              <a:t>•  Refresh, then Save-As a new dated file</a:t>
+              <a:t>•  Update the report tab, then save a new file</a:t>
             </a:r>
           </a:p>
         </p:txBody>
@@ -11402,7 +11402,7 @@
                 </a:solidFill>
                 <a:latin typeface="Calibri"/>
               </a:rPr>
-              <a:t>AFTER  —  hands-off</a:t>
+              <a:t>After:  it runs on its own</a:t>
             </a:r>
           </a:p>
         </p:txBody>
@@ -11441,7 +11441,7 @@
                 </a:solidFill>
                 <a:latin typeface="Calibri"/>
               </a:rPr>
-              <a:t>•  File lands in the shared folder → flow fires</a:t>
+              <a:t>•  The file lands in the shared folder and the flow starts</a:t>
             </a:r>
           </a:p>
           <a:p>
@@ -11457,7 +11457,7 @@
                 </a:solidFill>
                 <a:latin typeface="Calibri"/>
               </a:rPr>
-              <a:t>•  Office Script reads &amp; maps today's rows</a:t>
+              <a:t>•  An Office Script reads and maps today's rows</a:t>
             </a:r>
           </a:p>
           <a:p>
@@ -11473,7 +11473,7 @@
                 </a:solidFill>
                 <a:latin typeface="Calibri"/>
               </a:rPr>
-              <a:t>•  New dated file built, carrying full history</a:t>
+              <a:t>•  A new dated file is built, carrying full history</a:t>
             </a:r>
           </a:p>
           <a:p>
@@ -11489,7 +11489,7 @@
                 </a:solidFill>
                 <a:latin typeface="Calibri"/>
               </a:rPr>
-              <a:t>•  Today's rows appended → dashboard updates</a:t>
+              <a:t>•  Today's rows are added and the dashboard updates</a:t>
             </a:r>
           </a:p>
         </p:txBody>
@@ -11574,7 +11574,7 @@
                 </a:solidFill>
                 <a:latin typeface="Calibri"/>
               </a:rPr>
-              <a:t>Built with:  Power Query (M)  ·  Office Scripts (TypeScript)  ·  Power Automate  ·  SharePoint</a:t>
+              <a:t>Built with  Power Query (M),  Office Scripts (TypeScript),  Power Automate,  and SharePoint</a:t>
             </a:r>
           </a:p>
           <a:p>
@@ -11590,7 +11590,7 @@
                 </a:solidFill>
                 <a:latin typeface="Calibri"/>
               </a:rPr>
-              <a:t>Includes duplicate protection and graceful handling of missing / incomplete data (e.g. month-start EUR gaps).</a:t>
+              <a:t>It also protects against duplicates and handles missing or incomplete data gracefully, such as month-start EUR gaps.</a:t>
             </a:r>
           </a:p>
         </p:txBody>
@@ -11935,7 +11935,7 @@
                 </a:solidFill>
                 <a:latin typeface="Calibri"/>
               </a:rPr>
-              <a:t>•  Automated 6 recurring weekly Statements of Account:  Arrow Electronics (5 countries) + Baker Hughes (1).</a:t>
+              <a:t>•  Automated 6 recurring weekly Statements of Account: Arrow Electronics across 5 countries, and Baker Hughes.</a:t>
             </a:r>
           </a:p>
           <a:p>
@@ -11951,7 +11951,7 @@
                 </a:solidFill>
                 <a:latin typeface="Calibri"/>
               </a:rPr>
-              <a:t>•  Auto-generated from START templates with the correct account filters, then auto-emailed — attachments included, internal stakeholders CC'd.</a:t>
+              <a:t>•  Generated from START templates with the right account filters, then emailed automatically with attachments and internal stakeholders CC'd.</a:t>
             </a:r>
           </a:p>
           <a:p>
@@ -11967,7 +11967,7 @@
                 </a:solidFill>
                 <a:latin typeface="Calibri"/>
               </a:rPr>
-              <a:t>•  Built as a configurable framework: new customers onboard by updating configuration (accounts, recipients, schedule, template), not by rebuilding the solution.</a:t>
+              <a:t>•  Built as a configurable framework, so new customers can be added by updating configuration (accounts, recipients, schedule, template) rather than rebuilding it.</a:t>
             </a:r>
           </a:p>
           <a:p>
@@ -11983,7 +11983,7 @@
                 </a:solidFill>
                 <a:latin typeface="Calibri"/>
               </a:rPr>
-              <a:t>•  Exception-based by design — collectors step in only for exceptions, and spend their time on collections instead of routine report generation.</a:t>
+              <a:t>•  Designed so collectors only step in for exceptions, and can spend more of their time on collections.</a:t>
             </a:r>
           </a:p>
         </p:txBody>
@@ -12070,7 +12070,7 @@
                 </a:solidFill>
                 <a:latin typeface="Calibri"/>
               </a:rPr>
-              <a:t>Honest scope:  2 customers live today (6 SOAs/week) on a framework designed to scale to the rest — the hard part (the reusable engine) is done.</a:t>
+              <a:t>To be clear on scope: two customers are live today, six SOAs a week, on a framework built so more can be added over time. The reusable engine is the part that is done.</a:t>
             </a:r>
           </a:p>
         </p:txBody>
@@ -12332,7 +12332,7 @@
                 </a:solidFill>
                 <a:latin typeface="Calibri"/>
               </a:rPr>
-              <a:t>Hours saved — with the math shown, conservatively</a:t>
+              <a:t>Time saved, with the math shown, kept deliberately conservative</a:t>
             </a:r>
           </a:p>
         </p:txBody>
@@ -12389,8 +12389,8 @@
         </p:nvSpPr>
         <p:spPr>
           <a:xfrm>
-            <a:off x="640080" y="2240280"/>
-            <a:ext cx="10881360" cy="658368"/>
+            <a:off x="640080" y="2194560"/>
+            <a:ext cx="10881360" cy="548640"/>
           </a:xfrm>
           <a:prstGeom prst="rect">
             <a:avLst/>
@@ -12433,8 +12433,8 @@
         </p:nvSpPr>
         <p:spPr>
           <a:xfrm>
-            <a:off x="777240" y="2240280"/>
-            <a:ext cx="4297680" cy="658368"/>
+            <a:off x="777240" y="2194560"/>
+            <a:ext cx="4297680" cy="548640"/>
           </a:xfrm>
           <a:prstGeom prst="rect">
             <a:avLst/>
@@ -12472,8 +12472,8 @@
         </p:nvSpPr>
         <p:spPr>
           <a:xfrm>
-            <a:off x="5349240" y="2240280"/>
-            <a:ext cx="1828800" cy="658368"/>
+            <a:off x="5349240" y="2194560"/>
+            <a:ext cx="1828800" cy="548640"/>
           </a:xfrm>
           <a:prstGeom prst="rect">
             <a:avLst/>
@@ -12511,8 +12511,8 @@
         </p:nvSpPr>
         <p:spPr>
           <a:xfrm>
-            <a:off x="7452360" y="2240280"/>
-            <a:ext cx="1828800" cy="658368"/>
+            <a:off x="7452360" y="2194560"/>
+            <a:ext cx="1828800" cy="548640"/>
           </a:xfrm>
           <a:prstGeom prst="rect">
             <a:avLst/>
@@ -12550,8 +12550,8 @@
         </p:nvSpPr>
         <p:spPr>
           <a:xfrm>
-            <a:off x="9555480" y="2240280"/>
-            <a:ext cx="1828800" cy="658368"/>
+            <a:off x="9555480" y="2194560"/>
+            <a:ext cx="1828800" cy="548640"/>
           </a:xfrm>
           <a:prstGeom prst="rect">
             <a:avLst/>
@@ -12589,8 +12589,8 @@
         </p:nvSpPr>
         <p:spPr>
           <a:xfrm>
-            <a:off x="640080" y="2898648"/>
-            <a:ext cx="10881360" cy="658368"/>
+            <a:off x="640080" y="2743200"/>
+            <a:ext cx="10881360" cy="548640"/>
           </a:xfrm>
           <a:prstGeom prst="rect">
             <a:avLst/>
@@ -12635,8 +12635,8 @@
         </p:nvSpPr>
         <p:spPr>
           <a:xfrm>
-            <a:off x="777240" y="2898648"/>
-            <a:ext cx="4297680" cy="658368"/>
+            <a:off x="777240" y="2743200"/>
+            <a:ext cx="4297680" cy="548640"/>
           </a:xfrm>
           <a:prstGeom prst="rect">
             <a:avLst/>
@@ -12661,7 +12661,7 @@
                 </a:solidFill>
                 <a:latin typeface="Calibri"/>
               </a:rPr>
-              <a:t>Daily data pipeline  (15 min × 5 days)</a:t>
+              <a:t>Daily data file  (15 min × 5 days)</a:t>
             </a:r>
           </a:p>
         </p:txBody>
@@ -12674,8 +12674,8 @@
         </p:nvSpPr>
         <p:spPr>
           <a:xfrm>
-            <a:off x="5349240" y="2898648"/>
-            <a:ext cx="1828800" cy="658368"/>
+            <a:off x="5349240" y="2743200"/>
+            <a:ext cx="1828800" cy="548640"/>
           </a:xfrm>
           <a:prstGeom prst="rect">
             <a:avLst/>
@@ -12713,8 +12713,8 @@
         </p:nvSpPr>
         <p:spPr>
           <a:xfrm>
-            <a:off x="7452360" y="2898648"/>
-            <a:ext cx="1828800" cy="658368"/>
+            <a:off x="7452360" y="2743200"/>
+            <a:ext cx="1828800" cy="548640"/>
           </a:xfrm>
           <a:prstGeom prst="rect">
             <a:avLst/>
@@ -12752,8 +12752,8 @@
         </p:nvSpPr>
         <p:spPr>
           <a:xfrm>
-            <a:off x="9555480" y="2898648"/>
-            <a:ext cx="1828800" cy="658368"/>
+            <a:off x="9555480" y="2743200"/>
+            <a:ext cx="1828800" cy="548640"/>
           </a:xfrm>
           <a:prstGeom prst="rect">
             <a:avLst/>
@@ -12791,8 +12791,8 @@
         </p:nvSpPr>
         <p:spPr>
           <a:xfrm>
-            <a:off x="640080" y="3557016"/>
-            <a:ext cx="10881360" cy="658368"/>
+            <a:off x="640080" y="3291840"/>
+            <a:ext cx="10881360" cy="548640"/>
           </a:xfrm>
           <a:prstGeom prst="rect">
             <a:avLst/>
@@ -12837,8 +12837,8 @@
         </p:nvSpPr>
         <p:spPr>
           <a:xfrm>
-            <a:off x="777240" y="3557016"/>
-            <a:ext cx="4297680" cy="658368"/>
+            <a:off x="777240" y="3291840"/>
+            <a:ext cx="4297680" cy="548640"/>
           </a:xfrm>
           <a:prstGeom prst="rect">
             <a:avLst/>
@@ -12863,7 +12863,7 @@
                 </a:solidFill>
                 <a:latin typeface="Calibri"/>
               </a:rPr>
-              <a:t>SOA automation  (6 SOAs × 30–60 min)</a:t>
+              <a:t>Daily report tab  (15–20 min × 5 days)</a:t>
             </a:r>
           </a:p>
         </p:txBody>
@@ -12876,8 +12876,8 @@
         </p:nvSpPr>
         <p:spPr>
           <a:xfrm>
-            <a:off x="5349240" y="3557016"/>
-            <a:ext cx="1828800" cy="658368"/>
+            <a:off x="5349240" y="3291840"/>
+            <a:ext cx="1828800" cy="548640"/>
           </a:xfrm>
           <a:prstGeom prst="rect">
             <a:avLst/>
@@ -12902,7 +12902,7 @@
                 </a:solidFill>
                 <a:latin typeface="Calibri"/>
               </a:rPr>
-              <a:t>3–6 hrs</a:t>
+              <a:t>1.25–1.7 hrs</a:t>
             </a:r>
           </a:p>
         </p:txBody>
@@ -12915,8 +12915,8 @@
         </p:nvSpPr>
         <p:spPr>
           <a:xfrm>
-            <a:off x="7452360" y="3557016"/>
-            <a:ext cx="1828800" cy="658368"/>
+            <a:off x="7452360" y="3291840"/>
+            <a:ext cx="1828800" cy="548640"/>
           </a:xfrm>
           <a:prstGeom prst="rect">
             <a:avLst/>
@@ -12941,7 +12941,7 @@
                 </a:solidFill>
                 <a:latin typeface="Calibri"/>
               </a:rPr>
-              <a:t>13–26 hrs</a:t>
+              <a:t>~5–7 hrs</a:t>
             </a:r>
           </a:p>
         </p:txBody>
@@ -12954,8 +12954,8 @@
         </p:nvSpPr>
         <p:spPr>
           <a:xfrm>
-            <a:off x="9555480" y="3557016"/>
-            <a:ext cx="1828800" cy="658368"/>
+            <a:off x="9555480" y="3291840"/>
+            <a:ext cx="1828800" cy="548640"/>
           </a:xfrm>
           <a:prstGeom prst="rect">
             <a:avLst/>
@@ -12980,7 +12980,7 @@
                 </a:solidFill>
                 <a:latin typeface="Calibri"/>
               </a:rPr>
-              <a:t>150–300 hrs</a:t>
+              <a:t>~63–83 hrs</a:t>
             </a:r>
           </a:p>
         </p:txBody>
@@ -12993,8 +12993,210 @@
         </p:nvSpPr>
         <p:spPr>
           <a:xfrm>
-            <a:off x="640080" y="4215384"/>
-            <a:ext cx="10881360" cy="658368"/>
+            <a:off x="640080" y="3840480"/>
+            <a:ext cx="10881360" cy="548640"/>
+          </a:xfrm>
+          <a:prstGeom prst="rect">
+            <a:avLst/>
+          </a:prstGeom>
+          <a:solidFill>
+            <a:srgbClr val="FFFFFF"/>
+          </a:solidFill>
+          <a:ln w="9525">
+            <a:solidFill>
+              <a:srgbClr val="E2E0DA"/>
+            </a:solidFill>
+          </a:ln>
+          <a:effectLst/>
+        </p:spPr>
+        <p:style>
+          <a:lnRef idx="1">
+            <a:schemeClr val="accent1"/>
+          </a:lnRef>
+          <a:fillRef idx="3">
+            <a:schemeClr val="accent1"/>
+          </a:fillRef>
+          <a:effectRef idx="2">
+            <a:schemeClr val="accent1"/>
+          </a:effectRef>
+          <a:fontRef idx="minor">
+            <a:schemeClr val="lt1"/>
+          </a:fontRef>
+        </p:style>
+        <p:txBody>
+          <a:bodyPr rtlCol="0" anchor="ctr"/>
+          <a:lstStyle/>
+          <a:p>
+            <a:pPr algn="ctr"/>
+          </a:p>
+        </p:txBody>
+      </p:sp>
+      <p:sp>
+        <p:nvSpPr>
+          <p:cNvPr id="23" name="TextBox 22"/>
+          <p:cNvSpPr txBox="1"/>
+          <p:nvPr/>
+        </p:nvSpPr>
+        <p:spPr>
+          <a:xfrm>
+            <a:off x="777240" y="3840480"/>
+            <a:ext cx="4297680" cy="548640"/>
+          </a:xfrm>
+          <a:prstGeom prst="rect">
+            <a:avLst/>
+          </a:prstGeom>
+          <a:noFill/>
+        </p:spPr>
+        <p:txBody>
+          <a:bodyPr wrap="square" anchor="ctr" lIns="0" rIns="0" tIns="0" bIns="0">
+            <a:spAutoFit/>
+          </a:bodyPr>
+          <a:lstStyle/>
+          <a:p>
+            <a:pPr algn="l">
+              <a:spcAft>
+                <a:spcPts val="600"/>
+              </a:spcAft>
+            </a:pPr>
+            <a:r>
+              <a:rPr sz="1300" b="1" i="0">
+                <a:solidFill>
+                  <a:srgbClr val="1A1D21"/>
+                </a:solidFill>
+                <a:latin typeface="Calibri"/>
+              </a:rPr>
+              <a:t>SOA automation  (6 SOAs × 30–60 min)</a:t>
+            </a:r>
+          </a:p>
+        </p:txBody>
+      </p:sp>
+      <p:sp>
+        <p:nvSpPr>
+          <p:cNvPr id="24" name="TextBox 23"/>
+          <p:cNvSpPr txBox="1"/>
+          <p:nvPr/>
+        </p:nvSpPr>
+        <p:spPr>
+          <a:xfrm>
+            <a:off x="5349240" y="3840480"/>
+            <a:ext cx="1828800" cy="548640"/>
+          </a:xfrm>
+          <a:prstGeom prst="rect">
+            <a:avLst/>
+          </a:prstGeom>
+          <a:noFill/>
+        </p:spPr>
+        <p:txBody>
+          <a:bodyPr wrap="square" anchor="ctr" lIns="0" rIns="0" tIns="0" bIns="0">
+            <a:spAutoFit/>
+          </a:bodyPr>
+          <a:lstStyle/>
+          <a:p>
+            <a:pPr algn="ctr">
+              <a:spcAft>
+                <a:spcPts val="600"/>
+              </a:spcAft>
+            </a:pPr>
+            <a:r>
+              <a:rPr sz="1300" b="0" i="0">
+                <a:solidFill>
+                  <a:srgbClr val="1A1D21"/>
+                </a:solidFill>
+                <a:latin typeface="Calibri"/>
+              </a:rPr>
+              <a:t>3–6 hrs</a:t>
+            </a:r>
+          </a:p>
+        </p:txBody>
+      </p:sp>
+      <p:sp>
+        <p:nvSpPr>
+          <p:cNvPr id="25" name="TextBox 24"/>
+          <p:cNvSpPr txBox="1"/>
+          <p:nvPr/>
+        </p:nvSpPr>
+        <p:spPr>
+          <a:xfrm>
+            <a:off x="7452360" y="3840480"/>
+            <a:ext cx="1828800" cy="548640"/>
+          </a:xfrm>
+          <a:prstGeom prst="rect">
+            <a:avLst/>
+          </a:prstGeom>
+          <a:noFill/>
+        </p:spPr>
+        <p:txBody>
+          <a:bodyPr wrap="square" anchor="ctr" lIns="0" rIns="0" tIns="0" bIns="0">
+            <a:spAutoFit/>
+          </a:bodyPr>
+          <a:lstStyle/>
+          <a:p>
+            <a:pPr algn="ctr">
+              <a:spcAft>
+                <a:spcPts val="600"/>
+              </a:spcAft>
+            </a:pPr>
+            <a:r>
+              <a:rPr sz="1300" b="0" i="0">
+                <a:solidFill>
+                  <a:srgbClr val="1A1D21"/>
+                </a:solidFill>
+                <a:latin typeface="Calibri"/>
+              </a:rPr>
+              <a:t>13–26 hrs</a:t>
+            </a:r>
+          </a:p>
+        </p:txBody>
+      </p:sp>
+      <p:sp>
+        <p:nvSpPr>
+          <p:cNvPr id="26" name="TextBox 25"/>
+          <p:cNvSpPr txBox="1"/>
+          <p:nvPr/>
+        </p:nvSpPr>
+        <p:spPr>
+          <a:xfrm>
+            <a:off x="9555480" y="3840480"/>
+            <a:ext cx="1828800" cy="548640"/>
+          </a:xfrm>
+          <a:prstGeom prst="rect">
+            <a:avLst/>
+          </a:prstGeom>
+          <a:noFill/>
+        </p:spPr>
+        <p:txBody>
+          <a:bodyPr wrap="square" anchor="ctr" lIns="0" rIns="0" tIns="0" bIns="0">
+            <a:spAutoFit/>
+          </a:bodyPr>
+          <a:lstStyle/>
+          <a:p>
+            <a:pPr algn="ctr">
+              <a:spcAft>
+                <a:spcPts val="600"/>
+              </a:spcAft>
+            </a:pPr>
+            <a:r>
+              <a:rPr sz="1300" b="0" i="0">
+                <a:solidFill>
+                  <a:srgbClr val="1A1D21"/>
+                </a:solidFill>
+                <a:latin typeface="Calibri"/>
+              </a:rPr>
+              <a:t>150–300 hrs</a:t>
+            </a:r>
+          </a:p>
+        </p:txBody>
+      </p:sp>
+      <p:sp>
+        <p:nvSpPr>
+          <p:cNvPr id="27" name="Rectangle 26"/>
+          <p:cNvSpPr/>
+          <p:nvPr/>
+        </p:nvSpPr>
+        <p:spPr>
+          <a:xfrm>
+            <a:off x="640080" y="4389120"/>
+            <a:ext cx="10881360" cy="548640"/>
           </a:xfrm>
           <a:prstGeom prst="rect">
             <a:avLst/>
@@ -13033,14 +13235,14 @@
       </p:sp>
       <p:sp>
         <p:nvSpPr>
-          <p:cNvPr id="23" name="Rectangle 22"/>
+          <p:cNvPr id="28" name="Rectangle 27"/>
           <p:cNvSpPr/>
           <p:nvPr/>
         </p:nvSpPr>
         <p:spPr>
           <a:xfrm>
-            <a:off x="640080" y="4215384"/>
-            <a:ext cx="50800" cy="658368"/>
+            <a:off x="640080" y="4389120"/>
+            <a:ext cx="50800" cy="548640"/>
           </a:xfrm>
           <a:prstGeom prst="rect">
             <a:avLst/>
@@ -13077,14 +13279,14 @@
       </p:sp>
       <p:sp>
         <p:nvSpPr>
-          <p:cNvPr id="24" name="TextBox 23"/>
+          <p:cNvPr id="29" name="TextBox 28"/>
           <p:cNvSpPr txBox="1"/>
           <p:nvPr/>
         </p:nvSpPr>
         <p:spPr>
           <a:xfrm>
-            <a:off x="777240" y="4215384"/>
-            <a:ext cx="4297680" cy="658368"/>
+            <a:off x="777240" y="4389120"/>
+            <a:ext cx="4297680" cy="548640"/>
           </a:xfrm>
           <a:prstGeom prst="rect">
             <a:avLst/>
@@ -13116,14 +13318,14 @@
       </p:sp>
       <p:sp>
         <p:nvSpPr>
-          <p:cNvPr id="25" name="TextBox 24"/>
+          <p:cNvPr id="30" name="TextBox 29"/>
           <p:cNvSpPr txBox="1"/>
           <p:nvPr/>
         </p:nvSpPr>
         <p:spPr>
           <a:xfrm>
-            <a:off x="5349240" y="4215384"/>
-            <a:ext cx="1828800" cy="658368"/>
+            <a:off x="5349240" y="4389120"/>
+            <a:ext cx="1828800" cy="548640"/>
           </a:xfrm>
           <a:prstGeom prst="rect">
             <a:avLst/>
@@ -13148,21 +13350,21 @@
                 </a:solidFill>
                 <a:latin typeface="Calibri"/>
               </a:rPr>
-              <a:t>~4–7 hrs</a:t>
-            </a:r>
-          </a:p>
-        </p:txBody>
-      </p:sp>
-      <p:sp>
-        <p:nvSpPr>
-          <p:cNvPr id="26" name="TextBox 25"/>
+              <a:t>~5.5–9 hrs</a:t>
+            </a:r>
+          </a:p>
+        </p:txBody>
+      </p:sp>
+      <p:sp>
+        <p:nvSpPr>
+          <p:cNvPr id="31" name="TextBox 30"/>
           <p:cNvSpPr txBox="1"/>
           <p:nvPr/>
         </p:nvSpPr>
         <p:spPr>
           <a:xfrm>
-            <a:off x="7452360" y="4215384"/>
-            <a:ext cx="1828800" cy="658368"/>
+            <a:off x="7452360" y="4389120"/>
+            <a:ext cx="1828800" cy="548640"/>
           </a:xfrm>
           <a:prstGeom prst="rect">
             <a:avLst/>
@@ -13187,21 +13389,21 @@
                 </a:solidFill>
                 <a:latin typeface="Calibri"/>
               </a:rPr>
-              <a:t>~18–31 hrs</a:t>
-            </a:r>
-          </a:p>
-        </p:txBody>
-      </p:sp>
-      <p:sp>
-        <p:nvSpPr>
-          <p:cNvPr id="27" name="TextBox 26"/>
+              <a:t>~24–38 hrs</a:t>
+            </a:r>
+          </a:p>
+        </p:txBody>
+      </p:sp>
+      <p:sp>
+        <p:nvSpPr>
+          <p:cNvPr id="32" name="TextBox 31"/>
           <p:cNvSpPr txBox="1"/>
           <p:nvPr/>
         </p:nvSpPr>
         <p:spPr>
           <a:xfrm>
-            <a:off x="9555480" y="4215384"/>
-            <a:ext cx="1828800" cy="658368"/>
+            <a:off x="9555480" y="4389120"/>
+            <a:ext cx="1828800" cy="548640"/>
           </a:xfrm>
           <a:prstGeom prst="rect">
             <a:avLst/>
@@ -13226,20 +13428,20 @@
                 </a:solidFill>
                 <a:latin typeface="Calibri"/>
               </a:rPr>
-              <a:t>~210–360 hrs</a:t>
-            </a:r>
-          </a:p>
-        </p:txBody>
-      </p:sp>
-      <p:sp>
-        <p:nvSpPr>
-          <p:cNvPr id="28" name="TextBox 27"/>
+              <a:t>~275–445 hrs</a:t>
+            </a:r>
+          </a:p>
+        </p:txBody>
+      </p:sp>
+      <p:sp>
+        <p:nvSpPr>
+          <p:cNvPr id="33" name="TextBox 32"/>
           <p:cNvSpPr txBox="1"/>
           <p:nvPr/>
         </p:nvSpPr>
         <p:spPr>
           <a:xfrm>
-            <a:off x="640080" y="5074920"/>
+            <a:off x="640080" y="5120640"/>
             <a:ext cx="10881360" cy="1188720"/>
           </a:xfrm>
           <a:prstGeom prst="rect">
@@ -13265,7 +13467,7 @@
                 </a:solidFill>
                 <a:latin typeface="Calibri"/>
               </a:rPr>
-              <a:t>≈ 5 to 9 full 40-hour work-weeks of collector time recovered per year.</a:t>
+              <a:t>That comes to roughly 7 to 11 full work-weeks of time given back to the team each year.</a:t>
             </a:r>
           </a:p>
           <a:p>
@@ -13281,14 +13483,14 @@
                 </a:solidFill>
                 <a:latin typeface="Calibri"/>
               </a:rPr>
-              <a:t>Assumptions (deliberately conservative):  5 business days/week; SOA at 30–60 min each, 6/week; figures EXCLUDE error-correction, rework, and downstream analysis time — which would push the number higher, not lower.</a:t>
-            </a:r>
-          </a:p>
-        </p:txBody>
-      </p:sp>
-      <p:sp>
-        <p:nvSpPr>
-          <p:cNvPr id="29" name="TextBox 28"/>
+              <a:t>The assumptions are kept conservative on purpose: 5 business days a week, SOAs at 30 to 60 minutes each, 6 a week. The figures leave out error-correction, rework, and analysis time, so the real number is likely higher.</a:t>
+            </a:r>
+          </a:p>
+        </p:txBody>
+      </p:sp>
+      <p:sp>
+        <p:nvSpPr>
+          <p:cNvPr id="34" name="TextBox 33"/>
           <p:cNvSpPr txBox="1"/>
           <p:nvPr/>
         </p:nvSpPr>
@@ -13327,7 +13529,7 @@
       </p:sp>
       <p:sp>
         <p:nvSpPr>
-          <p:cNvPr id="30" name="TextBox 29"/>
+          <p:cNvPr id="35" name="TextBox 34"/>
           <p:cNvSpPr txBox="1"/>
           <p:nvPr/>
         </p:nvSpPr>

</xml_diff>

<commit_message>
Add reflective Challenges and Self-Reflection slides to internship deck
Added 'The Bigger Challenge Wasn't the Code' (learning the business,
cleaning fragmented data, building real production systems, undocumented
processes) and 'What I'd Do Differently' (design up front, document while
building, validate with users, grow from builder toward architect). Kept
DHL-facing improvement points out of the slides as talking points rather
than lecturing leadership. 20 slides.
</commit_message>
<xml_diff>
--- a/docs/AMKAD_Internship_Presentation.pptx
+++ b/docs/AMKAD_Internship_Presentation.pptx
@@ -23,6 +23,8 @@
     <p:sldId id="271" r:id="rId22"/>
     <p:sldId id="272" r:id="rId23"/>
     <p:sldId id="273" r:id="rId24"/>
+    <p:sldId id="274" r:id="rId25"/>
+    <p:sldId id="275" r:id="rId26"/>
   </p:sldIdLst>
   <p:sldSz cx="12191695" cy="6858000" type="screen4x3"/>
   <p:notesSz cx="6858000" cy="9144000"/>
@@ -6930,7 +6932,7 @@
                 </a:solidFill>
                 <a:latin typeface="Calibri"/>
               </a:rPr>
-              <a:t>WHAT I LEARNED</a:t>
+              <a:t>THE BIGGER CHALLENGE WASN'T THE CODE</a:t>
             </a:r>
           </a:p>
         </p:txBody>
@@ -7013,7 +7015,7 @@
                 </a:solidFill>
                 <a:latin typeface="Calibri"/>
               </a:rPr>
-              <a:t>The parts that will stay with me</a:t>
+              <a:t>The hardest parts were the ones around the building</a:t>
             </a:r>
           </a:p>
         </p:txBody>
@@ -7070,7 +7072,7 @@
         </p:nvSpPr>
         <p:spPr>
           <a:xfrm>
-            <a:off x="640080" y="2286000"/>
+            <a:off x="640080" y="2240280"/>
             <a:ext cx="10881360" cy="4023360"/>
           </a:xfrm>
           <a:prstGeom prst="rect">
@@ -7086,81 +7088,81 @@
           <a:p>
             <a:pPr algn="l">
               <a:spcAft>
-                <a:spcPts val="1300"/>
-              </a:spcAft>
-            </a:pPr>
-            <a:r>
-              <a:rPr sz="1550" b="0" i="0">
+                <a:spcPts val="1200"/>
+              </a:spcAft>
+            </a:pPr>
+            <a:r>
+              <a:rPr sz="1500" b="0" i="0">
                 <a:solidFill>
                   <a:srgbClr val="1A1D21"/>
                 </a:solidFill>
                 <a:latin typeface="Calibri"/>
               </a:rPr>
-              <a:t>•  How accounts receivable connects to the wider health and performance of the business.</a:t>
-            </a:r>
-          </a:p>
-          <a:p>
-            <a:pPr algn="l">
-              <a:spcAft>
-                <a:spcPts val="1300"/>
-              </a:spcAft>
-            </a:pPr>
-            <a:r>
-              <a:rPr sz="1550" b="0" i="0">
+              <a:t>•  Learning the business first: AR, aging, UAC, DSO, SOAs, START, and the AMKAD workflows, before automating any of it.</a:t>
+            </a:r>
+          </a:p>
+          <a:p>
+            <a:pPr algn="l">
+              <a:spcAft>
+                <a:spcPts val="1200"/>
+              </a:spcAft>
+            </a:pPr>
+            <a:r>
+              <a:rPr sz="1500" b="0" i="0">
                 <a:solidFill>
                   <a:srgbClr val="1A1D21"/>
                 </a:solidFill>
                 <a:latin typeface="Calibri"/>
               </a:rPr>
-              <a:t>•  How to take a business problem and turn it into a practical automation opportunity.</a:t>
-            </a:r>
-          </a:p>
-          <a:p>
-            <a:pPr algn="l">
-              <a:spcAft>
-                <a:spcPts val="1300"/>
-              </a:spcAft>
-            </a:pPr>
-            <a:r>
-              <a:rPr sz="1550" b="0" i="0">
+              <a:t>•  Understanding why collectors did each step, what the exceptions were, and what could break if I got it wrong.</a:t>
+            </a:r>
+          </a:p>
+          <a:p>
+            <a:pPr algn="l">
+              <a:spcAft>
+                <a:spcPts val="1200"/>
+              </a:spcAft>
+            </a:pPr>
+            <a:r>
+              <a:rPr sz="1500" b="0" i="0">
                 <a:solidFill>
                   <a:srgbClr val="1A1D21"/>
                 </a:solidFill>
                 <a:latin typeface="Calibri"/>
               </a:rPr>
-              <a:t>•  How to work with people across finance, collections, and IT to get something built.</a:t>
-            </a:r>
-          </a:p>
-          <a:p>
-            <a:pPr algn="l">
-              <a:spcAft>
-                <a:spcPts val="1300"/>
-              </a:spcAft>
-            </a:pPr>
-            <a:r>
-              <a:rPr sz="1550" b="0" i="0">
+              <a:t>•  Making imperfect, fragmented data reliable: different files, SAP exports, missing values, and inconsistent naming.</a:t>
+            </a:r>
+          </a:p>
+          <a:p>
+            <a:pPr algn="l">
+              <a:spcAft>
+                <a:spcPts val="1200"/>
+              </a:spcAft>
+            </a:pPr>
+            <a:r>
+              <a:rPr sz="1500" b="0" i="0">
                 <a:solidFill>
                   <a:srgbClr val="1A1D21"/>
                 </a:solidFill>
                 <a:latin typeface="Calibri"/>
               </a:rPr>
-              <a:t>•  Why it is worth designing scalable, reusable solutions instead of one-off fixes.</a:t>
-            </a:r>
-          </a:p>
-          <a:p>
-            <a:pPr algn="l">
-              <a:spcAft>
-                <a:spcPts val="1300"/>
-              </a:spcAft>
-            </a:pPr>
-            <a:r>
-              <a:rPr sz="1550" b="0" i="0">
+              <a:t>•  Building systems people actually depend on, where accuracy and uptime matter, not demo projects.</a:t>
+            </a:r>
+          </a:p>
+          <a:p>
+            <a:pPr algn="l">
+              <a:spcAft>
+                <a:spcPts val="1200"/>
+              </a:spcAft>
+            </a:pPr>
+            <a:r>
+              <a:rPr sz="1500" b="0" i="0">
                 <a:solidFill>
                   <a:srgbClr val="1A1D21"/>
                 </a:solidFill>
                 <a:latin typeface="Calibri"/>
               </a:rPr>
-              <a:t>•  How to stay calm and methodical when something breaks, and recover from it properly.</a:t>
+              <a:t>•  Piecing together processes that were never fully documented, by meeting people, asking questions, and testing.</a:t>
             </a:r>
           </a:p>
         </p:txBody>
@@ -7339,7 +7341,7 @@
                 </a:solidFill>
                 <a:latin typeface="Calibri"/>
               </a:rPr>
-              <a:t>WHAT IT TOOK</a:t>
+              <a:t>WHAT I LEARNED</a:t>
             </a:r>
           </a:p>
         </p:txBody>
@@ -7422,7 +7424,7 @@
                 </a:solidFill>
                 <a:latin typeface="Calibri"/>
               </a:rPr>
-              <a:t>Skills I got to build and use</a:t>
+              <a:t>The parts that will stay with me</a:t>
             </a:r>
           </a:p>
         </p:txBody>
@@ -7473,106 +7475,14 @@
       </p:sp>
       <p:sp>
         <p:nvSpPr>
-          <p:cNvPr id="7" name="Rounded Rectangle 6"/>
-          <p:cNvSpPr/>
+          <p:cNvPr id="7" name="TextBox 6"/>
+          <p:cNvSpPr txBox="1"/>
           <p:nvPr/>
         </p:nvSpPr>
         <p:spPr>
           <a:xfrm>
             <a:off x="640080" y="2286000"/>
-            <a:ext cx="5349240" cy="1828800"/>
-          </a:xfrm>
-          <a:prstGeom prst="roundRect">
-            <a:avLst>
-              <a:gd name="adj" fmla="val 7000"/>
-            </a:avLst>
-          </a:prstGeom>
-          <a:solidFill>
-            <a:srgbClr val="FFFFFF"/>
-          </a:solidFill>
-          <a:ln w="9525">
-            <a:solidFill>
-              <a:srgbClr val="E2E0DA"/>
-            </a:solidFill>
-          </a:ln>
-          <a:effectLst/>
-        </p:spPr>
-        <p:style>
-          <a:lnRef idx="1">
-            <a:schemeClr val="accent1"/>
-          </a:lnRef>
-          <a:fillRef idx="3">
-            <a:schemeClr val="accent1"/>
-          </a:fillRef>
-          <a:effectRef idx="2">
-            <a:schemeClr val="accent1"/>
-          </a:effectRef>
-          <a:fontRef idx="minor">
-            <a:schemeClr val="lt1"/>
-          </a:fontRef>
-        </p:style>
-        <p:txBody>
-          <a:bodyPr rtlCol="0" anchor="ctr"/>
-          <a:lstStyle/>
-          <a:p>
-            <a:pPr algn="ctr"/>
-          </a:p>
-        </p:txBody>
-      </p:sp>
-      <p:sp>
-        <p:nvSpPr>
-          <p:cNvPr id="8" name="Rectangle 7"/>
-          <p:cNvSpPr/>
-          <p:nvPr/>
-        </p:nvSpPr>
-        <p:spPr>
-          <a:xfrm>
-            <a:off x="640080" y="2286000"/>
-            <a:ext cx="50800" cy="1828800"/>
-          </a:xfrm>
-          <a:prstGeom prst="rect">
-            <a:avLst/>
-          </a:prstGeom>
-          <a:solidFill>
-            <a:srgbClr val="D40511"/>
-          </a:solidFill>
-          <a:ln>
-            <a:noFill/>
-          </a:ln>
-          <a:effectLst/>
-        </p:spPr>
-        <p:style>
-          <a:lnRef idx="1">
-            <a:schemeClr val="accent1"/>
-          </a:lnRef>
-          <a:fillRef idx="3">
-            <a:schemeClr val="accent1"/>
-          </a:fillRef>
-          <a:effectRef idx="2">
-            <a:schemeClr val="accent1"/>
-          </a:effectRef>
-          <a:fontRef idx="minor">
-            <a:schemeClr val="lt1"/>
-          </a:fontRef>
-        </p:style>
-        <p:txBody>
-          <a:bodyPr rtlCol="0" anchor="ctr"/>
-          <a:lstStyle/>
-          <a:p>
-            <a:pPr algn="ctr"/>
-          </a:p>
-        </p:txBody>
-      </p:sp>
-      <p:sp>
-        <p:nvSpPr>
-          <p:cNvPr id="9" name="TextBox 8"/>
-          <p:cNvSpPr txBox="1"/>
-          <p:nvPr/>
-        </p:nvSpPr>
-        <p:spPr>
-          <a:xfrm>
-            <a:off x="868680" y="2450592"/>
-            <a:ext cx="4937760" cy="1554480"/>
+            <a:ext cx="10881360" cy="4023360"/>
           </a:xfrm>
           <a:prstGeom prst="rect">
             <a:avLst/>
@@ -7587,187 +7497,95 @@
           <a:p>
             <a:pPr algn="l">
               <a:spcAft>
-                <a:spcPts val="700"/>
-              </a:spcAft>
-            </a:pPr>
-            <a:r>
-              <a:rPr sz="1400" b="1" i="0">
-                <a:solidFill>
-                  <a:srgbClr val="A5040D"/>
-                </a:solidFill>
-                <a:latin typeface="Calibri"/>
-              </a:rPr>
-              <a:t>Automation &amp; Data</a:t>
-            </a:r>
-          </a:p>
-          <a:p>
-            <a:pPr algn="l">
-              <a:spcAft>
-                <a:spcPts val="400"/>
-              </a:spcAft>
-            </a:pPr>
-            <a:r>
-              <a:rPr sz="1250" b="0" i="0">
+                <a:spcPts val="1300"/>
+              </a:spcAft>
+            </a:pPr>
+            <a:r>
+              <a:rPr sz="1550" b="0" i="0">
                 <a:solidFill>
                   <a:srgbClr val="1A1D21"/>
                 </a:solidFill>
                 <a:latin typeface="Calibri"/>
               </a:rPr>
-              <a:t>•  Power Query (M)</a:t>
-            </a:r>
-          </a:p>
-          <a:p>
-            <a:pPr algn="l">
-              <a:spcAft>
-                <a:spcPts val="400"/>
-              </a:spcAft>
-            </a:pPr>
-            <a:r>
-              <a:rPr sz="1250" b="0" i="0">
+              <a:t>•  How accounts receivable connects to the wider health and performance of the business.</a:t>
+            </a:r>
+          </a:p>
+          <a:p>
+            <a:pPr algn="l">
+              <a:spcAft>
+                <a:spcPts val="1300"/>
+              </a:spcAft>
+            </a:pPr>
+            <a:r>
+              <a:rPr sz="1550" b="0" i="0">
                 <a:solidFill>
                   <a:srgbClr val="1A1D21"/>
                 </a:solidFill>
                 <a:latin typeface="Calibri"/>
               </a:rPr>
-              <a:t>•  Office Scripts (TypeScript)</a:t>
-            </a:r>
-          </a:p>
-          <a:p>
-            <a:pPr algn="l">
-              <a:spcAft>
-                <a:spcPts val="400"/>
-              </a:spcAft>
-            </a:pPr>
-            <a:r>
-              <a:rPr sz="1250" b="0" i="0">
+              <a:t>•  How to take a business problem and turn it into a practical automation opportunity.</a:t>
+            </a:r>
+          </a:p>
+          <a:p>
+            <a:pPr algn="l">
+              <a:spcAft>
+                <a:spcPts val="1300"/>
+              </a:spcAft>
+            </a:pPr>
+            <a:r>
+              <a:rPr sz="1550" b="0" i="0">
                 <a:solidFill>
                   <a:srgbClr val="1A1D21"/>
                 </a:solidFill>
                 <a:latin typeface="Calibri"/>
               </a:rPr>
-              <a:t>•  Power Automate</a:t>
-            </a:r>
-          </a:p>
-          <a:p>
-            <a:pPr algn="l">
-              <a:spcAft>
-                <a:spcPts val="400"/>
-              </a:spcAft>
-            </a:pPr>
-            <a:r>
-              <a:rPr sz="1250" b="0" i="0">
+              <a:t>•  How to work with people across finance, collections, and IT to get something built.</a:t>
+            </a:r>
+          </a:p>
+          <a:p>
+            <a:pPr algn="l">
+              <a:spcAft>
+                <a:spcPts val="1300"/>
+              </a:spcAft>
+            </a:pPr>
+            <a:r>
+              <a:rPr sz="1550" b="0" i="0">
                 <a:solidFill>
                   <a:srgbClr val="1A1D21"/>
                 </a:solidFill>
                 <a:latin typeface="Calibri"/>
               </a:rPr>
-              <a:t>•  SharePoint / GitHub Actions</a:t>
-            </a:r>
-          </a:p>
-        </p:txBody>
-      </p:sp>
-      <p:sp>
-        <p:nvSpPr>
-          <p:cNvPr id="10" name="Rounded Rectangle 9"/>
-          <p:cNvSpPr/>
-          <p:nvPr/>
-        </p:nvSpPr>
-        <p:spPr>
-          <a:xfrm>
-            <a:off x="6217920" y="2286000"/>
-            <a:ext cx="5349240" cy="1828800"/>
-          </a:xfrm>
-          <a:prstGeom prst="roundRect">
-            <a:avLst>
-              <a:gd name="adj" fmla="val 7000"/>
-            </a:avLst>
-          </a:prstGeom>
-          <a:solidFill>
-            <a:srgbClr val="FFFFFF"/>
-          </a:solidFill>
-          <a:ln w="9525">
-            <a:solidFill>
-              <a:srgbClr val="E2E0DA"/>
-            </a:solidFill>
-          </a:ln>
-          <a:effectLst/>
-        </p:spPr>
-        <p:style>
-          <a:lnRef idx="1">
-            <a:schemeClr val="accent1"/>
-          </a:lnRef>
-          <a:fillRef idx="3">
-            <a:schemeClr val="accent1"/>
-          </a:fillRef>
-          <a:effectRef idx="2">
-            <a:schemeClr val="accent1"/>
-          </a:effectRef>
-          <a:fontRef idx="minor">
-            <a:schemeClr val="lt1"/>
-          </a:fontRef>
-        </p:style>
-        <p:txBody>
-          <a:bodyPr rtlCol="0" anchor="ctr"/>
-          <a:lstStyle/>
-          <a:p>
-            <a:pPr algn="ctr"/>
-          </a:p>
-        </p:txBody>
-      </p:sp>
-      <p:sp>
-        <p:nvSpPr>
-          <p:cNvPr id="11" name="Rectangle 10"/>
-          <p:cNvSpPr/>
-          <p:nvPr/>
-        </p:nvSpPr>
-        <p:spPr>
-          <a:xfrm>
-            <a:off x="6217920" y="2286000"/>
-            <a:ext cx="50800" cy="1828800"/>
-          </a:xfrm>
-          <a:prstGeom prst="rect">
-            <a:avLst/>
-          </a:prstGeom>
-          <a:solidFill>
-            <a:srgbClr val="D40511"/>
-          </a:solidFill>
-          <a:ln>
-            <a:noFill/>
-          </a:ln>
-          <a:effectLst/>
-        </p:spPr>
-        <p:style>
-          <a:lnRef idx="1">
-            <a:schemeClr val="accent1"/>
-          </a:lnRef>
-          <a:fillRef idx="3">
-            <a:schemeClr val="accent1"/>
-          </a:fillRef>
-          <a:effectRef idx="2">
-            <a:schemeClr val="accent1"/>
-          </a:effectRef>
-          <a:fontRef idx="minor">
-            <a:schemeClr val="lt1"/>
-          </a:fontRef>
-        </p:style>
-        <p:txBody>
-          <a:bodyPr rtlCol="0" anchor="ctr"/>
-          <a:lstStyle/>
-          <a:p>
-            <a:pPr algn="ctr"/>
-          </a:p>
-        </p:txBody>
-      </p:sp>
-      <p:sp>
-        <p:nvSpPr>
-          <p:cNvPr id="12" name="TextBox 11"/>
+              <a:t>•  Why it is worth designing scalable, reusable solutions instead of one-off fixes.</a:t>
+            </a:r>
+          </a:p>
+          <a:p>
+            <a:pPr algn="l">
+              <a:spcAft>
+                <a:spcPts val="1300"/>
+              </a:spcAft>
+            </a:pPr>
+            <a:r>
+              <a:rPr sz="1550" b="0" i="0">
+                <a:solidFill>
+                  <a:srgbClr val="1A1D21"/>
+                </a:solidFill>
+                <a:latin typeface="Calibri"/>
+              </a:rPr>
+              <a:t>•  How to stay calm and methodical when something breaks, and recover from it properly.</a:t>
+            </a:r>
+          </a:p>
+        </p:txBody>
+      </p:sp>
+      <p:sp>
+        <p:nvSpPr>
+          <p:cNvPr id="8" name="TextBox 7"/>
           <p:cNvSpPr txBox="1"/>
           <p:nvPr/>
         </p:nvSpPr>
         <p:spPr>
           <a:xfrm>
-            <a:off x="6446520" y="2450592"/>
-            <a:ext cx="4937760" cy="1554480"/>
+            <a:off x="640080" y="6537960"/>
+            <a:ext cx="8229600" cy="274320"/>
           </a:xfrm>
           <a:prstGeom prst="rect">
             <a:avLst/>
@@ -7782,499 +7600,6 @@
           <a:p>
             <a:pPr algn="l">
               <a:spcAft>
-                <a:spcPts val="700"/>
-              </a:spcAft>
-            </a:pPr>
-            <a:r>
-              <a:rPr sz="1400" b="1" i="0">
-                <a:solidFill>
-                  <a:srgbClr val="A5040D"/>
-                </a:solidFill>
-                <a:latin typeface="Calibri"/>
-              </a:rPr>
-              <a:t>Analysis &amp; Modeling</a:t>
-            </a:r>
-          </a:p>
-          <a:p>
-            <a:pPr algn="l">
-              <a:spcAft>
-                <a:spcPts val="400"/>
-              </a:spcAft>
-            </a:pPr>
-            <a:r>
-              <a:rPr sz="1250" b="0" i="0">
-                <a:solidFill>
-                  <a:srgbClr val="1A1D21"/>
-                </a:solidFill>
-                <a:latin typeface="Calibri"/>
-              </a:rPr>
-              <a:t>•  AR aging &amp; cash-application logic</a:t>
-            </a:r>
-          </a:p>
-          <a:p>
-            <a:pPr algn="l">
-              <a:spcAft>
-                <a:spcPts val="400"/>
-              </a:spcAft>
-            </a:pPr>
-            <a:r>
-              <a:rPr sz="1250" b="0" i="0">
-                <a:solidFill>
-                  <a:srgbClr val="1A1D21"/>
-                </a:solidFill>
-                <a:latin typeface="Calibri"/>
-              </a:rPr>
-              <a:t>•  Data consolidation &amp; modeling</a:t>
-            </a:r>
-          </a:p>
-          <a:p>
-            <a:pPr algn="l">
-              <a:spcAft>
-                <a:spcPts val="400"/>
-              </a:spcAft>
-            </a:pPr>
-            <a:r>
-              <a:rPr sz="1250" b="0" i="0">
-                <a:solidFill>
-                  <a:srgbClr val="1A1D21"/>
-                </a:solidFill>
-                <a:latin typeface="Calibri"/>
-              </a:rPr>
-              <a:t>•  Power BI</a:t>
-            </a:r>
-          </a:p>
-          <a:p>
-            <a:pPr algn="l">
-              <a:spcAft>
-                <a:spcPts val="400"/>
-              </a:spcAft>
-            </a:pPr>
-            <a:r>
-              <a:rPr sz="1250" b="0" i="0">
-                <a:solidFill>
-                  <a:srgbClr val="1A1D21"/>
-                </a:solidFill>
-                <a:latin typeface="Calibri"/>
-              </a:rPr>
-              <a:t>•  MTD / snapshot filtering</a:t>
-            </a:r>
-          </a:p>
-        </p:txBody>
-      </p:sp>
-      <p:sp>
-        <p:nvSpPr>
-          <p:cNvPr id="13" name="Rounded Rectangle 12"/>
-          <p:cNvSpPr/>
-          <p:nvPr/>
-        </p:nvSpPr>
-        <p:spPr>
-          <a:xfrm>
-            <a:off x="640080" y="4343400"/>
-            <a:ext cx="5349240" cy="1828800"/>
-          </a:xfrm>
-          <a:prstGeom prst="roundRect">
-            <a:avLst>
-              <a:gd name="adj" fmla="val 7000"/>
-            </a:avLst>
-          </a:prstGeom>
-          <a:solidFill>
-            <a:srgbClr val="FFFFFF"/>
-          </a:solidFill>
-          <a:ln w="9525">
-            <a:solidFill>
-              <a:srgbClr val="E2E0DA"/>
-            </a:solidFill>
-          </a:ln>
-          <a:effectLst/>
-        </p:spPr>
-        <p:style>
-          <a:lnRef idx="1">
-            <a:schemeClr val="accent1"/>
-          </a:lnRef>
-          <a:fillRef idx="3">
-            <a:schemeClr val="accent1"/>
-          </a:fillRef>
-          <a:effectRef idx="2">
-            <a:schemeClr val="accent1"/>
-          </a:effectRef>
-          <a:fontRef idx="minor">
-            <a:schemeClr val="lt1"/>
-          </a:fontRef>
-        </p:style>
-        <p:txBody>
-          <a:bodyPr rtlCol="0" anchor="ctr"/>
-          <a:lstStyle/>
-          <a:p>
-            <a:pPr algn="ctr"/>
-          </a:p>
-        </p:txBody>
-      </p:sp>
-      <p:sp>
-        <p:nvSpPr>
-          <p:cNvPr id="14" name="Rectangle 13"/>
-          <p:cNvSpPr/>
-          <p:nvPr/>
-        </p:nvSpPr>
-        <p:spPr>
-          <a:xfrm>
-            <a:off x="640080" y="4343400"/>
-            <a:ext cx="50800" cy="1828800"/>
-          </a:xfrm>
-          <a:prstGeom prst="rect">
-            <a:avLst/>
-          </a:prstGeom>
-          <a:solidFill>
-            <a:srgbClr val="D40511"/>
-          </a:solidFill>
-          <a:ln>
-            <a:noFill/>
-          </a:ln>
-          <a:effectLst/>
-        </p:spPr>
-        <p:style>
-          <a:lnRef idx="1">
-            <a:schemeClr val="accent1"/>
-          </a:lnRef>
-          <a:fillRef idx="3">
-            <a:schemeClr val="accent1"/>
-          </a:fillRef>
-          <a:effectRef idx="2">
-            <a:schemeClr val="accent1"/>
-          </a:effectRef>
-          <a:fontRef idx="minor">
-            <a:schemeClr val="lt1"/>
-          </a:fontRef>
-        </p:style>
-        <p:txBody>
-          <a:bodyPr rtlCol="0" anchor="ctr"/>
-          <a:lstStyle/>
-          <a:p>
-            <a:pPr algn="ctr"/>
-          </a:p>
-        </p:txBody>
-      </p:sp>
-      <p:sp>
-        <p:nvSpPr>
-          <p:cNvPr id="15" name="TextBox 14"/>
-          <p:cNvSpPr txBox="1"/>
-          <p:nvPr/>
-        </p:nvSpPr>
-        <p:spPr>
-          <a:xfrm>
-            <a:off x="868680" y="4507992"/>
-            <a:ext cx="4937760" cy="1554480"/>
-          </a:xfrm>
-          <a:prstGeom prst="rect">
-            <a:avLst/>
-          </a:prstGeom>
-          <a:noFill/>
-        </p:spPr>
-        <p:txBody>
-          <a:bodyPr wrap="square" anchor="t" lIns="0" rIns="0" tIns="0" bIns="0">
-            <a:spAutoFit/>
-          </a:bodyPr>
-          <a:lstStyle/>
-          <a:p>
-            <a:pPr algn="l">
-              <a:spcAft>
-                <a:spcPts val="700"/>
-              </a:spcAft>
-            </a:pPr>
-            <a:r>
-              <a:rPr sz="1400" b="1" i="0">
-                <a:solidFill>
-                  <a:srgbClr val="A5040D"/>
-                </a:solidFill>
-                <a:latin typeface="Calibri"/>
-              </a:rPr>
-              <a:t>Product &amp; Front-End</a:t>
-            </a:r>
-          </a:p>
-          <a:p>
-            <a:pPr algn="l">
-              <a:spcAft>
-                <a:spcPts val="400"/>
-              </a:spcAft>
-            </a:pPr>
-            <a:r>
-              <a:rPr sz="1250" b="0" i="0">
-                <a:solidFill>
-                  <a:srgbClr val="1A1D21"/>
-                </a:solidFill>
-                <a:latin typeface="Calibri"/>
-              </a:rPr>
-              <a:t>•  HTML / CSS / JavaScript</a:t>
-            </a:r>
-          </a:p>
-          <a:p>
-            <a:pPr algn="l">
-              <a:spcAft>
-                <a:spcPts val="400"/>
-              </a:spcAft>
-            </a:pPr>
-            <a:r>
-              <a:rPr sz="1250" b="0" i="0">
-                <a:solidFill>
-                  <a:srgbClr val="1A1D21"/>
-                </a:solidFill>
-                <a:latin typeface="Calibri"/>
-              </a:rPr>
-              <a:t>•  SVG charting &amp; dashboards</a:t>
-            </a:r>
-          </a:p>
-          <a:p>
-            <a:pPr algn="l">
-              <a:spcAft>
-                <a:spcPts val="400"/>
-              </a:spcAft>
-            </a:pPr>
-            <a:r>
-              <a:rPr sz="1250" b="0" i="0">
-                <a:solidFill>
-                  <a:srgbClr val="1A1D21"/>
-                </a:solidFill>
-                <a:latin typeface="Calibri"/>
-              </a:rPr>
-              <a:t>•  UX for non-technical users</a:t>
-            </a:r>
-          </a:p>
-          <a:p>
-            <a:pPr algn="l">
-              <a:spcAft>
-                <a:spcPts val="400"/>
-              </a:spcAft>
-            </a:pPr>
-            <a:r>
-              <a:rPr sz="1250" b="0" i="0">
-                <a:solidFill>
-                  <a:srgbClr val="1A1D21"/>
-                </a:solidFill>
-                <a:latin typeface="Calibri"/>
-              </a:rPr>
-              <a:t>•  Clear documentation</a:t>
-            </a:r>
-          </a:p>
-        </p:txBody>
-      </p:sp>
-      <p:sp>
-        <p:nvSpPr>
-          <p:cNvPr id="16" name="Rounded Rectangle 15"/>
-          <p:cNvSpPr/>
-          <p:nvPr/>
-        </p:nvSpPr>
-        <p:spPr>
-          <a:xfrm>
-            <a:off x="6217920" y="4343400"/>
-            <a:ext cx="5349240" cy="1828800"/>
-          </a:xfrm>
-          <a:prstGeom prst="roundRect">
-            <a:avLst>
-              <a:gd name="adj" fmla="val 7000"/>
-            </a:avLst>
-          </a:prstGeom>
-          <a:solidFill>
-            <a:srgbClr val="FFFFFF"/>
-          </a:solidFill>
-          <a:ln w="9525">
-            <a:solidFill>
-              <a:srgbClr val="E2E0DA"/>
-            </a:solidFill>
-          </a:ln>
-          <a:effectLst/>
-        </p:spPr>
-        <p:style>
-          <a:lnRef idx="1">
-            <a:schemeClr val="accent1"/>
-          </a:lnRef>
-          <a:fillRef idx="3">
-            <a:schemeClr val="accent1"/>
-          </a:fillRef>
-          <a:effectRef idx="2">
-            <a:schemeClr val="accent1"/>
-          </a:effectRef>
-          <a:fontRef idx="minor">
-            <a:schemeClr val="lt1"/>
-          </a:fontRef>
-        </p:style>
-        <p:txBody>
-          <a:bodyPr rtlCol="0" anchor="ctr"/>
-          <a:lstStyle/>
-          <a:p>
-            <a:pPr algn="ctr"/>
-          </a:p>
-        </p:txBody>
-      </p:sp>
-      <p:sp>
-        <p:nvSpPr>
-          <p:cNvPr id="17" name="Rectangle 16"/>
-          <p:cNvSpPr/>
-          <p:nvPr/>
-        </p:nvSpPr>
-        <p:spPr>
-          <a:xfrm>
-            <a:off x="6217920" y="4343400"/>
-            <a:ext cx="50800" cy="1828800"/>
-          </a:xfrm>
-          <a:prstGeom prst="rect">
-            <a:avLst/>
-          </a:prstGeom>
-          <a:solidFill>
-            <a:srgbClr val="D40511"/>
-          </a:solidFill>
-          <a:ln>
-            <a:noFill/>
-          </a:ln>
-          <a:effectLst/>
-        </p:spPr>
-        <p:style>
-          <a:lnRef idx="1">
-            <a:schemeClr val="accent1"/>
-          </a:lnRef>
-          <a:fillRef idx="3">
-            <a:schemeClr val="accent1"/>
-          </a:fillRef>
-          <a:effectRef idx="2">
-            <a:schemeClr val="accent1"/>
-          </a:effectRef>
-          <a:fontRef idx="minor">
-            <a:schemeClr val="lt1"/>
-          </a:fontRef>
-        </p:style>
-        <p:txBody>
-          <a:bodyPr rtlCol="0" anchor="ctr"/>
-          <a:lstStyle/>
-          <a:p>
-            <a:pPr algn="ctr"/>
-          </a:p>
-        </p:txBody>
-      </p:sp>
-      <p:sp>
-        <p:nvSpPr>
-          <p:cNvPr id="18" name="TextBox 17"/>
-          <p:cNvSpPr txBox="1"/>
-          <p:nvPr/>
-        </p:nvSpPr>
-        <p:spPr>
-          <a:xfrm>
-            <a:off x="6446520" y="4507992"/>
-            <a:ext cx="4937760" cy="1554480"/>
-          </a:xfrm>
-          <a:prstGeom prst="rect">
-            <a:avLst/>
-          </a:prstGeom>
-          <a:noFill/>
-        </p:spPr>
-        <p:txBody>
-          <a:bodyPr wrap="square" anchor="t" lIns="0" rIns="0" tIns="0" bIns="0">
-            <a:spAutoFit/>
-          </a:bodyPr>
-          <a:lstStyle/>
-          <a:p>
-            <a:pPr algn="l">
-              <a:spcAft>
-                <a:spcPts val="700"/>
-              </a:spcAft>
-            </a:pPr>
-            <a:r>
-              <a:rPr sz="1400" b="1" i="0">
-                <a:solidFill>
-                  <a:srgbClr val="A5040D"/>
-                </a:solidFill>
-                <a:latin typeface="Calibri"/>
-              </a:rPr>
-              <a:t>Ways of Working</a:t>
-            </a:r>
-          </a:p>
-          <a:p>
-            <a:pPr algn="l">
-              <a:spcAft>
-                <a:spcPts val="400"/>
-              </a:spcAft>
-            </a:pPr>
-            <a:r>
-              <a:rPr sz="1250" b="0" i="0">
-                <a:solidFill>
-                  <a:srgbClr val="1A1D21"/>
-                </a:solidFill>
-                <a:latin typeface="Calibri"/>
-              </a:rPr>
-              <a:t>•  Reverse-engineering undocumented processes</a:t>
-            </a:r>
-          </a:p>
-          <a:p>
-            <a:pPr algn="l">
-              <a:spcAft>
-                <a:spcPts val="400"/>
-              </a:spcAft>
-            </a:pPr>
-            <a:r>
-              <a:rPr sz="1250" b="0" i="0">
-                <a:solidFill>
-                  <a:srgbClr val="1A1D21"/>
-                </a:solidFill>
-                <a:latin typeface="Calibri"/>
-              </a:rPr>
-              <a:t>•  Working from ambiguity</a:t>
-            </a:r>
-          </a:p>
-          <a:p>
-            <a:pPr algn="l">
-              <a:spcAft>
-                <a:spcPts val="400"/>
-              </a:spcAft>
-            </a:pPr>
-            <a:r>
-              <a:rPr sz="1250" b="0" i="0">
-                <a:solidFill>
-                  <a:srgbClr val="1A1D21"/>
-                </a:solidFill>
-                <a:latin typeface="Calibri"/>
-              </a:rPr>
-              <a:t>•  Production troubleshooting</a:t>
-            </a:r>
-          </a:p>
-          <a:p>
-            <a:pPr algn="l">
-              <a:spcAft>
-                <a:spcPts val="400"/>
-              </a:spcAft>
-            </a:pPr>
-            <a:r>
-              <a:rPr sz="1250" b="0" i="0">
-                <a:solidFill>
-                  <a:srgbClr val="1A1D21"/>
-                </a:solidFill>
-                <a:latin typeface="Calibri"/>
-              </a:rPr>
-              <a:t>•  Following things through to done</a:t>
-            </a:r>
-          </a:p>
-        </p:txBody>
-      </p:sp>
-      <p:sp>
-        <p:nvSpPr>
-          <p:cNvPr id="19" name="TextBox 18"/>
-          <p:cNvSpPr txBox="1"/>
-          <p:nvPr/>
-        </p:nvSpPr>
-        <p:spPr>
-          <a:xfrm>
-            <a:off x="640080" y="6537960"/>
-            <a:ext cx="8229600" cy="274320"/>
-          </a:xfrm>
-          <a:prstGeom prst="rect">
-            <a:avLst/>
-          </a:prstGeom>
-          <a:noFill/>
-        </p:spPr>
-        <p:txBody>
-          <a:bodyPr wrap="square" anchor="t" lIns="0" rIns="0" tIns="0" bIns="0">
-            <a:spAutoFit/>
-          </a:bodyPr>
-          <a:lstStyle/>
-          <a:p>
-            <a:pPr algn="l">
-              <a:spcAft>
                 <a:spcPts val="600"/>
               </a:spcAft>
             </a:pPr>
@@ -8292,7 +7617,7 @@
       </p:sp>
       <p:sp>
         <p:nvSpPr>
-          <p:cNvPr id="20" name="TextBox 19"/>
+          <p:cNvPr id="9" name="TextBox 8"/>
           <p:cNvSpPr txBox="1"/>
           <p:nvPr/>
         </p:nvSpPr>
@@ -8425,7 +7750,7 @@
                 </a:solidFill>
                 <a:latin typeface="Calibri"/>
               </a:rPr>
-              <a:t>WHAT I'M MOST PROUD OF</a:t>
+              <a:t>WHAT I'D DO DIFFERENTLY</a:t>
             </a:r>
           </a:p>
         </p:txBody>
@@ -8508,7 +7833,7 @@
                 </a:solidFill>
                 <a:latin typeface="Calibri"/>
               </a:rPr>
-              <a:t>A few things that meant the most to me</a:t>
+              <a:t>Where I want to grow from here</a:t>
             </a:r>
           </a:p>
         </p:txBody>
@@ -8581,7 +7906,7 @@
           <a:p>
             <a:pPr algn="l">
               <a:spcAft>
-                <a:spcPts val="1300"/>
+                <a:spcPts val="1500"/>
               </a:spcAft>
             </a:pPr>
             <a:r>
@@ -8591,13 +7916,13 @@
                 </a:solidFill>
                 <a:latin typeface="Calibri"/>
               </a:rPr>
-              <a:t>•  Building three automation solutions that are genuinely in use, not just prototypes.</a:t>
-            </a:r>
-          </a:p>
-          <a:p>
-            <a:pPr algn="l">
-              <a:spcAft>
-                <a:spcPts val="1300"/>
+              <a:t>•  Spend more time on design up front. Map the process and sketch the architecture before building, so there is less rebuilding later when a new requirement appears.</a:t>
+            </a:r>
+          </a:p>
+          <a:p>
+            <a:pPr algn="l">
+              <a:spcAft>
+                <a:spcPts val="1500"/>
               </a:spcAft>
             </a:pPr>
             <a:r>
@@ -8607,13 +7932,13 @@
                 </a:solidFill>
                 <a:latin typeface="Calibri"/>
               </a:rPr>
-              <a:t>•  Taking real, repetitive reporting effort off the team's plate each day.</a:t>
-            </a:r>
-          </a:p>
-          <a:p>
-            <a:pPr algn="l">
-              <a:spcAft>
-                <a:spcPts val="1300"/>
+              <a:t>•  Document while I build, not at the end. As the automations grew more complex, earlier notes would have made them easier to hand off and maintain.</a:t>
+            </a:r>
+          </a:p>
+          <a:p>
+            <a:pPr algn="l">
+              <a:spcAft>
+                <a:spcPts val="1500"/>
               </a:spcAft>
             </a:pPr>
             <a:r>
@@ -8623,46 +7948,101 @@
                 </a:solidFill>
                 <a:latin typeface="Calibri"/>
               </a:rPr>
-              <a:t>•  Creating reusable frameworks that can grow, rather than one-time fixes.</a:t>
-            </a:r>
-          </a:p>
-          <a:p>
-            <a:pPr algn="l">
-              <a:spcAft>
-                <a:spcPts val="1300"/>
-              </a:spcAft>
-            </a:pPr>
-            <a:r>
-              <a:rPr sz="1550" b="0" i="0">
-                <a:solidFill>
-                  <a:srgbClr val="1A1D21"/>
-                </a:solidFill>
-                <a:latin typeface="Calibri"/>
-              </a:rPr>
-              <a:t>•  Leaving behind solutions that keep running after the internship ends.</a:t>
-            </a:r>
-          </a:p>
-          <a:p>
-            <a:pPr algn="l">
-              <a:spcAft>
-                <a:spcPts val="1300"/>
-              </a:spcAft>
-            </a:pPr>
-            <a:r>
-              <a:rPr sz="1550" b="0" i="0">
-                <a:solidFill>
-                  <a:srgbClr val="1A1D21"/>
-                </a:solidFill>
-                <a:latin typeface="Calibri"/>
-              </a:rPr>
-              <a:t>•  Giving the team clearer visibility into AR performance and collections activity.</a:t>
-            </a:r>
-          </a:p>
-        </p:txBody>
-      </p:sp>
-      <p:sp>
-        <p:nvSpPr>
-          <p:cNvPr id="8" name="TextBox 7"/>
+              <a:t>•  Validate the workflow with users earlier and more often. Not just "can I make this work," but "is this the workflow people actually want."</a:t>
+            </a:r>
+          </a:p>
+        </p:txBody>
+      </p:sp>
+      <p:sp>
+        <p:nvSpPr>
+          <p:cNvPr id="8" name="Rounded Rectangle 7"/>
+          <p:cNvSpPr/>
+          <p:nvPr/>
+        </p:nvSpPr>
+        <p:spPr>
+          <a:xfrm>
+            <a:off x="640080" y="5257800"/>
+            <a:ext cx="10881360" cy="822960"/>
+          </a:xfrm>
+          <a:prstGeom prst="roundRect">
+            <a:avLst>
+              <a:gd name="adj" fmla="val 10000"/>
+            </a:avLst>
+          </a:prstGeom>
+          <a:solidFill>
+            <a:srgbClr val="FCEFEF"/>
+          </a:solidFill>
+          <a:ln w="9525">
+            <a:solidFill>
+              <a:srgbClr val="E2E0DA"/>
+            </a:solidFill>
+          </a:ln>
+          <a:effectLst/>
+        </p:spPr>
+        <p:style>
+          <a:lnRef idx="1">
+            <a:schemeClr val="accent1"/>
+          </a:lnRef>
+          <a:fillRef idx="3">
+            <a:schemeClr val="accent1"/>
+          </a:fillRef>
+          <a:effectRef idx="2">
+            <a:schemeClr val="accent1"/>
+          </a:effectRef>
+          <a:fontRef idx="minor">
+            <a:schemeClr val="lt1"/>
+          </a:fontRef>
+        </p:style>
+        <p:txBody>
+          <a:bodyPr rtlCol="0" anchor="ctr"/>
+          <a:lstStyle/>
+          <a:p>
+            <a:pPr algn="ctr"/>
+          </a:p>
+        </p:txBody>
+      </p:sp>
+      <p:sp>
+        <p:nvSpPr>
+          <p:cNvPr id="9" name="TextBox 8"/>
+          <p:cNvSpPr txBox="1"/>
+          <p:nvPr/>
+        </p:nvSpPr>
+        <p:spPr>
+          <a:xfrm>
+            <a:off x="914400" y="5349240"/>
+            <a:ext cx="10332720" cy="640080"/>
+          </a:xfrm>
+          <a:prstGeom prst="rect">
+            <a:avLst/>
+          </a:prstGeom>
+          <a:noFill/>
+        </p:spPr>
+        <p:txBody>
+          <a:bodyPr wrap="square" anchor="ctr" lIns="0" rIns="0" tIns="0" bIns="0">
+            <a:spAutoFit/>
+          </a:bodyPr>
+          <a:lstStyle/>
+          <a:p>
+            <a:pPr algn="l">
+              <a:spcAft>
+                <a:spcPts val="600"/>
+              </a:spcAft>
+            </a:pPr>
+            <a:r>
+              <a:rPr sz="1350" b="1" i="0">
+                <a:solidFill>
+                  <a:srgbClr val="A5040D"/>
+                </a:solidFill>
+                <a:latin typeface="Calibri"/>
+              </a:rPr>
+              <a:t>In short, I want to grow from building automations toward designing them: more thought up front, better documentation, and scalability from the start.</a:t>
+            </a:r>
+          </a:p>
+        </p:txBody>
+      </p:sp>
+      <p:sp>
+        <p:nvSpPr>
+          <p:cNvPr id="10" name="TextBox 9"/>
           <p:cNvSpPr txBox="1"/>
           <p:nvPr/>
         </p:nvSpPr>
@@ -8701,7 +8081,7 @@
       </p:sp>
       <p:sp>
         <p:nvSpPr>
-          <p:cNvPr id="9" name="TextBox 8"/>
+          <p:cNvPr id="11" name="TextBox 10"/>
           <p:cNvSpPr txBox="1"/>
           <p:nvPr/>
         </p:nvSpPr>
@@ -8834,7 +8214,7 @@
                 </a:solidFill>
                 <a:latin typeface="Calibri"/>
               </a:rPr>
-              <a:t>WHAT'S NEXT</a:t>
+              <a:t>WHAT IT TOOK</a:t>
             </a:r>
           </a:p>
         </p:txBody>
@@ -8917,7 +8297,7 @@
                 </a:solidFill>
                 <a:latin typeface="Calibri"/>
               </a:rPr>
-              <a:t>How this can grow from here</a:t>
+              <a:t>Skills I got to build and use</a:t>
             </a:r>
           </a:p>
         </p:txBody>
@@ -8968,14 +8348,106 @@
       </p:sp>
       <p:sp>
         <p:nvSpPr>
-          <p:cNvPr id="7" name="TextBox 6"/>
+          <p:cNvPr id="7" name="Rounded Rectangle 6"/>
+          <p:cNvSpPr/>
+          <p:nvPr/>
+        </p:nvSpPr>
+        <p:spPr>
+          <a:xfrm>
+            <a:off x="640080" y="2286000"/>
+            <a:ext cx="5349240" cy="1828800"/>
+          </a:xfrm>
+          <a:prstGeom prst="roundRect">
+            <a:avLst>
+              <a:gd name="adj" fmla="val 7000"/>
+            </a:avLst>
+          </a:prstGeom>
+          <a:solidFill>
+            <a:srgbClr val="FFFFFF"/>
+          </a:solidFill>
+          <a:ln w="9525">
+            <a:solidFill>
+              <a:srgbClr val="E2E0DA"/>
+            </a:solidFill>
+          </a:ln>
+          <a:effectLst/>
+        </p:spPr>
+        <p:style>
+          <a:lnRef idx="1">
+            <a:schemeClr val="accent1"/>
+          </a:lnRef>
+          <a:fillRef idx="3">
+            <a:schemeClr val="accent1"/>
+          </a:fillRef>
+          <a:effectRef idx="2">
+            <a:schemeClr val="accent1"/>
+          </a:effectRef>
+          <a:fontRef idx="minor">
+            <a:schemeClr val="lt1"/>
+          </a:fontRef>
+        </p:style>
+        <p:txBody>
+          <a:bodyPr rtlCol="0" anchor="ctr"/>
+          <a:lstStyle/>
+          <a:p>
+            <a:pPr algn="ctr"/>
+          </a:p>
+        </p:txBody>
+      </p:sp>
+      <p:sp>
+        <p:nvSpPr>
+          <p:cNvPr id="8" name="Rectangle 7"/>
+          <p:cNvSpPr/>
+          <p:nvPr/>
+        </p:nvSpPr>
+        <p:spPr>
+          <a:xfrm>
+            <a:off x="640080" y="2286000"/>
+            <a:ext cx="50800" cy="1828800"/>
+          </a:xfrm>
+          <a:prstGeom prst="rect">
+            <a:avLst/>
+          </a:prstGeom>
+          <a:solidFill>
+            <a:srgbClr val="D40511"/>
+          </a:solidFill>
+          <a:ln>
+            <a:noFill/>
+          </a:ln>
+          <a:effectLst/>
+        </p:spPr>
+        <p:style>
+          <a:lnRef idx="1">
+            <a:schemeClr val="accent1"/>
+          </a:lnRef>
+          <a:fillRef idx="3">
+            <a:schemeClr val="accent1"/>
+          </a:fillRef>
+          <a:effectRef idx="2">
+            <a:schemeClr val="accent1"/>
+          </a:effectRef>
+          <a:fontRef idx="minor">
+            <a:schemeClr val="lt1"/>
+          </a:fontRef>
+        </p:style>
+        <p:txBody>
+          <a:bodyPr rtlCol="0" anchor="ctr"/>
+          <a:lstStyle/>
+          <a:p>
+            <a:pPr algn="ctr"/>
+          </a:p>
+        </p:txBody>
+      </p:sp>
+      <p:sp>
+        <p:nvSpPr>
+          <p:cNvPr id="9" name="TextBox 8"/>
           <p:cNvSpPr txBox="1"/>
           <p:nvPr/>
         </p:nvSpPr>
         <p:spPr>
           <a:xfrm>
-            <a:off x="640080" y="2286000"/>
-            <a:ext cx="10881360" cy="4023360"/>
+            <a:off x="868680" y="2450592"/>
+            <a:ext cx="4937760" cy="1554480"/>
           </a:xfrm>
           <a:prstGeom prst="rect">
             <a:avLst/>
@@ -8990,79 +8462,187 @@
           <a:p>
             <a:pPr algn="l">
               <a:spcAft>
-                <a:spcPts val="1300"/>
-              </a:spcAft>
-            </a:pPr>
-            <a:r>
-              <a:rPr sz="1550" b="0" i="0">
+                <a:spcPts val="700"/>
+              </a:spcAft>
+            </a:pPr>
+            <a:r>
+              <a:rPr sz="1400" b="1" i="0">
+                <a:solidFill>
+                  <a:srgbClr val="A5040D"/>
+                </a:solidFill>
+                <a:latin typeface="Calibri"/>
+              </a:rPr>
+              <a:t>Automation &amp; Data</a:t>
+            </a:r>
+          </a:p>
+          <a:p>
+            <a:pPr algn="l">
+              <a:spcAft>
+                <a:spcPts val="400"/>
+              </a:spcAft>
+            </a:pPr>
+            <a:r>
+              <a:rPr sz="1250" b="0" i="0">
                 <a:solidFill>
                   <a:srgbClr val="1A1D21"/>
                 </a:solidFill>
                 <a:latin typeface="Calibri"/>
               </a:rPr>
-              <a:t>•  Extend the SOA framework to more customers and countries, since the reusable engine is already in place.</a:t>
-            </a:r>
-          </a:p>
-          <a:p>
-            <a:pPr algn="l">
-              <a:spcAft>
-                <a:spcPts val="1300"/>
-              </a:spcAft>
-            </a:pPr>
-            <a:r>
-              <a:rPr sz="1550" b="0" i="0">
+              <a:t>•  Power Query (M)</a:t>
+            </a:r>
+          </a:p>
+          <a:p>
+            <a:pPr algn="l">
+              <a:spcAft>
+                <a:spcPts val="400"/>
+              </a:spcAft>
+            </a:pPr>
+            <a:r>
+              <a:rPr sz="1250" b="0" i="0">
                 <a:solidFill>
                   <a:srgbClr val="1A1D21"/>
                 </a:solidFill>
                 <a:latin typeface="Calibri"/>
               </a:rPr>
-              <a:t>•  Move the data layer toward a centralized database (SQL and Data Factory), which would be a stronger backbone for everything above.</a:t>
-            </a:r>
-          </a:p>
-          <a:p>
-            <a:pPr algn="l">
-              <a:spcAft>
-                <a:spcPts val="1300"/>
-              </a:spcAft>
-            </a:pPr>
-            <a:r>
-              <a:rPr sz="1550" b="0" i="0">
+              <a:t>•  Office Scripts (TypeScript)</a:t>
+            </a:r>
+          </a:p>
+          <a:p>
+            <a:pPr algn="l">
+              <a:spcAft>
+                <a:spcPts val="400"/>
+              </a:spcAft>
+            </a:pPr>
+            <a:r>
+              <a:rPr sz="1250" b="0" i="0">
                 <a:solidFill>
                   <a:srgbClr val="1A1D21"/>
                 </a:solidFill>
                 <a:latin typeface="Calibri"/>
               </a:rPr>
-              <a:t>•  Build leadership-facing Power BI dashboards on top of the same consolidated data.</a:t>
-            </a:r>
-          </a:p>
-          <a:p>
-            <a:pPr algn="l">
-              <a:spcAft>
-                <a:spcPts val="1300"/>
-              </a:spcAft>
-            </a:pPr>
-            <a:r>
-              <a:rPr sz="1550" b="0" i="0">
+              <a:t>•  Power Automate</a:t>
+            </a:r>
+          </a:p>
+          <a:p>
+            <a:pPr algn="l">
+              <a:spcAft>
+                <a:spcPts val="400"/>
+              </a:spcAft>
+            </a:pPr>
+            <a:r>
+              <a:rPr sz="1250" b="0" i="0">
                 <a:solidFill>
                   <a:srgbClr val="1A1D21"/>
                 </a:solidFill>
                 <a:latin typeface="Calibri"/>
               </a:rPr>
-              <a:t>•  Small hardening steps, like standardizing the monthly folder names and adding alerts for missing or late source files.</a:t>
-            </a:r>
-          </a:p>
-        </p:txBody>
-      </p:sp>
-      <p:sp>
-        <p:nvSpPr>
-          <p:cNvPr id="8" name="TextBox 7"/>
+              <a:t>•  SharePoint / GitHub Actions</a:t>
+            </a:r>
+          </a:p>
+        </p:txBody>
+      </p:sp>
+      <p:sp>
+        <p:nvSpPr>
+          <p:cNvPr id="10" name="Rounded Rectangle 9"/>
+          <p:cNvSpPr/>
+          <p:nvPr/>
+        </p:nvSpPr>
+        <p:spPr>
+          <a:xfrm>
+            <a:off x="6217920" y="2286000"/>
+            <a:ext cx="5349240" cy="1828800"/>
+          </a:xfrm>
+          <a:prstGeom prst="roundRect">
+            <a:avLst>
+              <a:gd name="adj" fmla="val 7000"/>
+            </a:avLst>
+          </a:prstGeom>
+          <a:solidFill>
+            <a:srgbClr val="FFFFFF"/>
+          </a:solidFill>
+          <a:ln w="9525">
+            <a:solidFill>
+              <a:srgbClr val="E2E0DA"/>
+            </a:solidFill>
+          </a:ln>
+          <a:effectLst/>
+        </p:spPr>
+        <p:style>
+          <a:lnRef idx="1">
+            <a:schemeClr val="accent1"/>
+          </a:lnRef>
+          <a:fillRef idx="3">
+            <a:schemeClr val="accent1"/>
+          </a:fillRef>
+          <a:effectRef idx="2">
+            <a:schemeClr val="accent1"/>
+          </a:effectRef>
+          <a:fontRef idx="minor">
+            <a:schemeClr val="lt1"/>
+          </a:fontRef>
+        </p:style>
+        <p:txBody>
+          <a:bodyPr rtlCol="0" anchor="ctr"/>
+          <a:lstStyle/>
+          <a:p>
+            <a:pPr algn="ctr"/>
+          </a:p>
+        </p:txBody>
+      </p:sp>
+      <p:sp>
+        <p:nvSpPr>
+          <p:cNvPr id="11" name="Rectangle 10"/>
+          <p:cNvSpPr/>
+          <p:nvPr/>
+        </p:nvSpPr>
+        <p:spPr>
+          <a:xfrm>
+            <a:off x="6217920" y="2286000"/>
+            <a:ext cx="50800" cy="1828800"/>
+          </a:xfrm>
+          <a:prstGeom prst="rect">
+            <a:avLst/>
+          </a:prstGeom>
+          <a:solidFill>
+            <a:srgbClr val="D40511"/>
+          </a:solidFill>
+          <a:ln>
+            <a:noFill/>
+          </a:ln>
+          <a:effectLst/>
+        </p:spPr>
+        <p:style>
+          <a:lnRef idx="1">
+            <a:schemeClr val="accent1"/>
+          </a:lnRef>
+          <a:fillRef idx="3">
+            <a:schemeClr val="accent1"/>
+          </a:fillRef>
+          <a:effectRef idx="2">
+            <a:schemeClr val="accent1"/>
+          </a:effectRef>
+          <a:fontRef idx="minor">
+            <a:schemeClr val="lt1"/>
+          </a:fontRef>
+        </p:style>
+        <p:txBody>
+          <a:bodyPr rtlCol="0" anchor="ctr"/>
+          <a:lstStyle/>
+          <a:p>
+            <a:pPr algn="ctr"/>
+          </a:p>
+        </p:txBody>
+      </p:sp>
+      <p:sp>
+        <p:nvSpPr>
+          <p:cNvPr id="12" name="TextBox 11"/>
           <p:cNvSpPr txBox="1"/>
           <p:nvPr/>
         </p:nvSpPr>
         <p:spPr>
           <a:xfrm>
-            <a:off x="640080" y="6537960"/>
-            <a:ext cx="8229600" cy="274320"/>
+            <a:off x="6446520" y="2450592"/>
+            <a:ext cx="4937760" cy="1554480"/>
           </a:xfrm>
           <a:prstGeom prst="rect">
             <a:avLst/>
@@ -9077,6 +8657,499 @@
           <a:p>
             <a:pPr algn="l">
               <a:spcAft>
+                <a:spcPts val="700"/>
+              </a:spcAft>
+            </a:pPr>
+            <a:r>
+              <a:rPr sz="1400" b="1" i="0">
+                <a:solidFill>
+                  <a:srgbClr val="A5040D"/>
+                </a:solidFill>
+                <a:latin typeface="Calibri"/>
+              </a:rPr>
+              <a:t>Analysis &amp; Modeling</a:t>
+            </a:r>
+          </a:p>
+          <a:p>
+            <a:pPr algn="l">
+              <a:spcAft>
+                <a:spcPts val="400"/>
+              </a:spcAft>
+            </a:pPr>
+            <a:r>
+              <a:rPr sz="1250" b="0" i="0">
+                <a:solidFill>
+                  <a:srgbClr val="1A1D21"/>
+                </a:solidFill>
+                <a:latin typeface="Calibri"/>
+              </a:rPr>
+              <a:t>•  AR aging &amp; cash-application logic</a:t>
+            </a:r>
+          </a:p>
+          <a:p>
+            <a:pPr algn="l">
+              <a:spcAft>
+                <a:spcPts val="400"/>
+              </a:spcAft>
+            </a:pPr>
+            <a:r>
+              <a:rPr sz="1250" b="0" i="0">
+                <a:solidFill>
+                  <a:srgbClr val="1A1D21"/>
+                </a:solidFill>
+                <a:latin typeface="Calibri"/>
+              </a:rPr>
+              <a:t>•  Data consolidation &amp; modeling</a:t>
+            </a:r>
+          </a:p>
+          <a:p>
+            <a:pPr algn="l">
+              <a:spcAft>
+                <a:spcPts val="400"/>
+              </a:spcAft>
+            </a:pPr>
+            <a:r>
+              <a:rPr sz="1250" b="0" i="0">
+                <a:solidFill>
+                  <a:srgbClr val="1A1D21"/>
+                </a:solidFill>
+                <a:latin typeface="Calibri"/>
+              </a:rPr>
+              <a:t>•  Power BI</a:t>
+            </a:r>
+          </a:p>
+          <a:p>
+            <a:pPr algn="l">
+              <a:spcAft>
+                <a:spcPts val="400"/>
+              </a:spcAft>
+            </a:pPr>
+            <a:r>
+              <a:rPr sz="1250" b="0" i="0">
+                <a:solidFill>
+                  <a:srgbClr val="1A1D21"/>
+                </a:solidFill>
+                <a:latin typeface="Calibri"/>
+              </a:rPr>
+              <a:t>•  MTD / snapshot filtering</a:t>
+            </a:r>
+          </a:p>
+        </p:txBody>
+      </p:sp>
+      <p:sp>
+        <p:nvSpPr>
+          <p:cNvPr id="13" name="Rounded Rectangle 12"/>
+          <p:cNvSpPr/>
+          <p:nvPr/>
+        </p:nvSpPr>
+        <p:spPr>
+          <a:xfrm>
+            <a:off x="640080" y="4343400"/>
+            <a:ext cx="5349240" cy="1828800"/>
+          </a:xfrm>
+          <a:prstGeom prst="roundRect">
+            <a:avLst>
+              <a:gd name="adj" fmla="val 7000"/>
+            </a:avLst>
+          </a:prstGeom>
+          <a:solidFill>
+            <a:srgbClr val="FFFFFF"/>
+          </a:solidFill>
+          <a:ln w="9525">
+            <a:solidFill>
+              <a:srgbClr val="E2E0DA"/>
+            </a:solidFill>
+          </a:ln>
+          <a:effectLst/>
+        </p:spPr>
+        <p:style>
+          <a:lnRef idx="1">
+            <a:schemeClr val="accent1"/>
+          </a:lnRef>
+          <a:fillRef idx="3">
+            <a:schemeClr val="accent1"/>
+          </a:fillRef>
+          <a:effectRef idx="2">
+            <a:schemeClr val="accent1"/>
+          </a:effectRef>
+          <a:fontRef idx="minor">
+            <a:schemeClr val="lt1"/>
+          </a:fontRef>
+        </p:style>
+        <p:txBody>
+          <a:bodyPr rtlCol="0" anchor="ctr"/>
+          <a:lstStyle/>
+          <a:p>
+            <a:pPr algn="ctr"/>
+          </a:p>
+        </p:txBody>
+      </p:sp>
+      <p:sp>
+        <p:nvSpPr>
+          <p:cNvPr id="14" name="Rectangle 13"/>
+          <p:cNvSpPr/>
+          <p:nvPr/>
+        </p:nvSpPr>
+        <p:spPr>
+          <a:xfrm>
+            <a:off x="640080" y="4343400"/>
+            <a:ext cx="50800" cy="1828800"/>
+          </a:xfrm>
+          <a:prstGeom prst="rect">
+            <a:avLst/>
+          </a:prstGeom>
+          <a:solidFill>
+            <a:srgbClr val="D40511"/>
+          </a:solidFill>
+          <a:ln>
+            <a:noFill/>
+          </a:ln>
+          <a:effectLst/>
+        </p:spPr>
+        <p:style>
+          <a:lnRef idx="1">
+            <a:schemeClr val="accent1"/>
+          </a:lnRef>
+          <a:fillRef idx="3">
+            <a:schemeClr val="accent1"/>
+          </a:fillRef>
+          <a:effectRef idx="2">
+            <a:schemeClr val="accent1"/>
+          </a:effectRef>
+          <a:fontRef idx="minor">
+            <a:schemeClr val="lt1"/>
+          </a:fontRef>
+        </p:style>
+        <p:txBody>
+          <a:bodyPr rtlCol="0" anchor="ctr"/>
+          <a:lstStyle/>
+          <a:p>
+            <a:pPr algn="ctr"/>
+          </a:p>
+        </p:txBody>
+      </p:sp>
+      <p:sp>
+        <p:nvSpPr>
+          <p:cNvPr id="15" name="TextBox 14"/>
+          <p:cNvSpPr txBox="1"/>
+          <p:nvPr/>
+        </p:nvSpPr>
+        <p:spPr>
+          <a:xfrm>
+            <a:off x="868680" y="4507992"/>
+            <a:ext cx="4937760" cy="1554480"/>
+          </a:xfrm>
+          <a:prstGeom prst="rect">
+            <a:avLst/>
+          </a:prstGeom>
+          <a:noFill/>
+        </p:spPr>
+        <p:txBody>
+          <a:bodyPr wrap="square" anchor="t" lIns="0" rIns="0" tIns="0" bIns="0">
+            <a:spAutoFit/>
+          </a:bodyPr>
+          <a:lstStyle/>
+          <a:p>
+            <a:pPr algn="l">
+              <a:spcAft>
+                <a:spcPts val="700"/>
+              </a:spcAft>
+            </a:pPr>
+            <a:r>
+              <a:rPr sz="1400" b="1" i="0">
+                <a:solidFill>
+                  <a:srgbClr val="A5040D"/>
+                </a:solidFill>
+                <a:latin typeface="Calibri"/>
+              </a:rPr>
+              <a:t>Product &amp; Front-End</a:t>
+            </a:r>
+          </a:p>
+          <a:p>
+            <a:pPr algn="l">
+              <a:spcAft>
+                <a:spcPts val="400"/>
+              </a:spcAft>
+            </a:pPr>
+            <a:r>
+              <a:rPr sz="1250" b="0" i="0">
+                <a:solidFill>
+                  <a:srgbClr val="1A1D21"/>
+                </a:solidFill>
+                <a:latin typeface="Calibri"/>
+              </a:rPr>
+              <a:t>•  HTML / CSS / JavaScript</a:t>
+            </a:r>
+          </a:p>
+          <a:p>
+            <a:pPr algn="l">
+              <a:spcAft>
+                <a:spcPts val="400"/>
+              </a:spcAft>
+            </a:pPr>
+            <a:r>
+              <a:rPr sz="1250" b="0" i="0">
+                <a:solidFill>
+                  <a:srgbClr val="1A1D21"/>
+                </a:solidFill>
+                <a:latin typeface="Calibri"/>
+              </a:rPr>
+              <a:t>•  SVG charting &amp; dashboards</a:t>
+            </a:r>
+          </a:p>
+          <a:p>
+            <a:pPr algn="l">
+              <a:spcAft>
+                <a:spcPts val="400"/>
+              </a:spcAft>
+            </a:pPr>
+            <a:r>
+              <a:rPr sz="1250" b="0" i="0">
+                <a:solidFill>
+                  <a:srgbClr val="1A1D21"/>
+                </a:solidFill>
+                <a:latin typeface="Calibri"/>
+              </a:rPr>
+              <a:t>•  UX for non-technical users</a:t>
+            </a:r>
+          </a:p>
+          <a:p>
+            <a:pPr algn="l">
+              <a:spcAft>
+                <a:spcPts val="400"/>
+              </a:spcAft>
+            </a:pPr>
+            <a:r>
+              <a:rPr sz="1250" b="0" i="0">
+                <a:solidFill>
+                  <a:srgbClr val="1A1D21"/>
+                </a:solidFill>
+                <a:latin typeface="Calibri"/>
+              </a:rPr>
+              <a:t>•  Clear documentation</a:t>
+            </a:r>
+          </a:p>
+        </p:txBody>
+      </p:sp>
+      <p:sp>
+        <p:nvSpPr>
+          <p:cNvPr id="16" name="Rounded Rectangle 15"/>
+          <p:cNvSpPr/>
+          <p:nvPr/>
+        </p:nvSpPr>
+        <p:spPr>
+          <a:xfrm>
+            <a:off x="6217920" y="4343400"/>
+            <a:ext cx="5349240" cy="1828800"/>
+          </a:xfrm>
+          <a:prstGeom prst="roundRect">
+            <a:avLst>
+              <a:gd name="adj" fmla="val 7000"/>
+            </a:avLst>
+          </a:prstGeom>
+          <a:solidFill>
+            <a:srgbClr val="FFFFFF"/>
+          </a:solidFill>
+          <a:ln w="9525">
+            <a:solidFill>
+              <a:srgbClr val="E2E0DA"/>
+            </a:solidFill>
+          </a:ln>
+          <a:effectLst/>
+        </p:spPr>
+        <p:style>
+          <a:lnRef idx="1">
+            <a:schemeClr val="accent1"/>
+          </a:lnRef>
+          <a:fillRef idx="3">
+            <a:schemeClr val="accent1"/>
+          </a:fillRef>
+          <a:effectRef idx="2">
+            <a:schemeClr val="accent1"/>
+          </a:effectRef>
+          <a:fontRef idx="minor">
+            <a:schemeClr val="lt1"/>
+          </a:fontRef>
+        </p:style>
+        <p:txBody>
+          <a:bodyPr rtlCol="0" anchor="ctr"/>
+          <a:lstStyle/>
+          <a:p>
+            <a:pPr algn="ctr"/>
+          </a:p>
+        </p:txBody>
+      </p:sp>
+      <p:sp>
+        <p:nvSpPr>
+          <p:cNvPr id="17" name="Rectangle 16"/>
+          <p:cNvSpPr/>
+          <p:nvPr/>
+        </p:nvSpPr>
+        <p:spPr>
+          <a:xfrm>
+            <a:off x="6217920" y="4343400"/>
+            <a:ext cx="50800" cy="1828800"/>
+          </a:xfrm>
+          <a:prstGeom prst="rect">
+            <a:avLst/>
+          </a:prstGeom>
+          <a:solidFill>
+            <a:srgbClr val="D40511"/>
+          </a:solidFill>
+          <a:ln>
+            <a:noFill/>
+          </a:ln>
+          <a:effectLst/>
+        </p:spPr>
+        <p:style>
+          <a:lnRef idx="1">
+            <a:schemeClr val="accent1"/>
+          </a:lnRef>
+          <a:fillRef idx="3">
+            <a:schemeClr val="accent1"/>
+          </a:fillRef>
+          <a:effectRef idx="2">
+            <a:schemeClr val="accent1"/>
+          </a:effectRef>
+          <a:fontRef idx="minor">
+            <a:schemeClr val="lt1"/>
+          </a:fontRef>
+        </p:style>
+        <p:txBody>
+          <a:bodyPr rtlCol="0" anchor="ctr"/>
+          <a:lstStyle/>
+          <a:p>
+            <a:pPr algn="ctr"/>
+          </a:p>
+        </p:txBody>
+      </p:sp>
+      <p:sp>
+        <p:nvSpPr>
+          <p:cNvPr id="18" name="TextBox 17"/>
+          <p:cNvSpPr txBox="1"/>
+          <p:nvPr/>
+        </p:nvSpPr>
+        <p:spPr>
+          <a:xfrm>
+            <a:off x="6446520" y="4507992"/>
+            <a:ext cx="4937760" cy="1554480"/>
+          </a:xfrm>
+          <a:prstGeom prst="rect">
+            <a:avLst/>
+          </a:prstGeom>
+          <a:noFill/>
+        </p:spPr>
+        <p:txBody>
+          <a:bodyPr wrap="square" anchor="t" lIns="0" rIns="0" tIns="0" bIns="0">
+            <a:spAutoFit/>
+          </a:bodyPr>
+          <a:lstStyle/>
+          <a:p>
+            <a:pPr algn="l">
+              <a:spcAft>
+                <a:spcPts val="700"/>
+              </a:spcAft>
+            </a:pPr>
+            <a:r>
+              <a:rPr sz="1400" b="1" i="0">
+                <a:solidFill>
+                  <a:srgbClr val="A5040D"/>
+                </a:solidFill>
+                <a:latin typeface="Calibri"/>
+              </a:rPr>
+              <a:t>Ways of Working</a:t>
+            </a:r>
+          </a:p>
+          <a:p>
+            <a:pPr algn="l">
+              <a:spcAft>
+                <a:spcPts val="400"/>
+              </a:spcAft>
+            </a:pPr>
+            <a:r>
+              <a:rPr sz="1250" b="0" i="0">
+                <a:solidFill>
+                  <a:srgbClr val="1A1D21"/>
+                </a:solidFill>
+                <a:latin typeface="Calibri"/>
+              </a:rPr>
+              <a:t>•  Reverse-engineering undocumented processes</a:t>
+            </a:r>
+          </a:p>
+          <a:p>
+            <a:pPr algn="l">
+              <a:spcAft>
+                <a:spcPts val="400"/>
+              </a:spcAft>
+            </a:pPr>
+            <a:r>
+              <a:rPr sz="1250" b="0" i="0">
+                <a:solidFill>
+                  <a:srgbClr val="1A1D21"/>
+                </a:solidFill>
+                <a:latin typeface="Calibri"/>
+              </a:rPr>
+              <a:t>•  Working from ambiguity</a:t>
+            </a:r>
+          </a:p>
+          <a:p>
+            <a:pPr algn="l">
+              <a:spcAft>
+                <a:spcPts val="400"/>
+              </a:spcAft>
+            </a:pPr>
+            <a:r>
+              <a:rPr sz="1250" b="0" i="0">
+                <a:solidFill>
+                  <a:srgbClr val="1A1D21"/>
+                </a:solidFill>
+                <a:latin typeface="Calibri"/>
+              </a:rPr>
+              <a:t>•  Production troubleshooting</a:t>
+            </a:r>
+          </a:p>
+          <a:p>
+            <a:pPr algn="l">
+              <a:spcAft>
+                <a:spcPts val="400"/>
+              </a:spcAft>
+            </a:pPr>
+            <a:r>
+              <a:rPr sz="1250" b="0" i="0">
+                <a:solidFill>
+                  <a:srgbClr val="1A1D21"/>
+                </a:solidFill>
+                <a:latin typeface="Calibri"/>
+              </a:rPr>
+              <a:t>•  Following things through to done</a:t>
+            </a:r>
+          </a:p>
+        </p:txBody>
+      </p:sp>
+      <p:sp>
+        <p:nvSpPr>
+          <p:cNvPr id="19" name="TextBox 18"/>
+          <p:cNvSpPr txBox="1"/>
+          <p:nvPr/>
+        </p:nvSpPr>
+        <p:spPr>
+          <a:xfrm>
+            <a:off x="640080" y="6537960"/>
+            <a:ext cx="8229600" cy="274320"/>
+          </a:xfrm>
+          <a:prstGeom prst="rect">
+            <a:avLst/>
+          </a:prstGeom>
+          <a:noFill/>
+        </p:spPr>
+        <p:txBody>
+          <a:bodyPr wrap="square" anchor="t" lIns="0" rIns="0" tIns="0" bIns="0">
+            <a:spAutoFit/>
+          </a:bodyPr>
+          <a:lstStyle/>
+          <a:p>
+            <a:pPr algn="l">
+              <a:spcAft>
                 <a:spcPts val="600"/>
               </a:spcAft>
             </a:pPr>
@@ -9094,7 +9167,7 @@
       </p:sp>
       <p:sp>
         <p:nvSpPr>
-          <p:cNvPr id="9" name="TextBox 8"/>
+          <p:cNvPr id="20" name="TextBox 19"/>
           <p:cNvSpPr txBox="1"/>
           <p:nvPr/>
         </p:nvSpPr>
@@ -9164,7 +9237,7 @@
             <a:avLst/>
           </a:prstGeom>
           <a:solidFill>
-            <a:srgbClr val="1A1D21"/>
+            <a:srgbClr val="F7F6F3"/>
           </a:solidFill>
           <a:ln>
             <a:noFill/>
@@ -9195,45 +9268,40 @@
       </p:sp>
       <p:sp>
         <p:nvSpPr>
-          <p:cNvPr id="3" name="Rectangle 2"/>
-          <p:cNvSpPr/>
-          <p:nvPr/>
-        </p:nvSpPr>
-        <p:spPr>
-          <a:xfrm>
-            <a:off x="0" y="0"/>
-            <a:ext cx="12191695" cy="146304"/>
-          </a:xfrm>
-          <a:prstGeom prst="rect">
-            <a:avLst/>
-          </a:prstGeom>
-          <a:solidFill>
-            <a:srgbClr val="D40511"/>
-          </a:solidFill>
-          <a:ln>
-            <a:noFill/>
-          </a:ln>
-          <a:effectLst/>
-        </p:spPr>
-        <p:style>
-          <a:lnRef idx="1">
-            <a:schemeClr val="accent1"/>
-          </a:lnRef>
-          <a:fillRef idx="3">
-            <a:schemeClr val="accent1"/>
-          </a:fillRef>
-          <a:effectRef idx="2">
-            <a:schemeClr val="accent1"/>
-          </a:effectRef>
-          <a:fontRef idx="minor">
-            <a:schemeClr val="lt1"/>
-          </a:fontRef>
-        </p:style>
-        <p:txBody>
-          <a:bodyPr rtlCol="0" anchor="ctr"/>
-          <a:lstStyle/>
-          <a:p>
-            <a:pPr algn="ctr"/>
+          <p:cNvPr id="3" name="TextBox 2"/>
+          <p:cNvSpPr txBox="1"/>
+          <p:nvPr/>
+        </p:nvSpPr>
+        <p:spPr>
+          <a:xfrm>
+            <a:off x="640080" y="457200"/>
+            <a:ext cx="10058400" cy="365760"/>
+          </a:xfrm>
+          <a:prstGeom prst="rect">
+            <a:avLst/>
+          </a:prstGeom>
+          <a:noFill/>
+        </p:spPr>
+        <p:txBody>
+          <a:bodyPr wrap="square" anchor="t" lIns="0" rIns="0" tIns="0" bIns="0">
+            <a:spAutoFit/>
+          </a:bodyPr>
+          <a:lstStyle/>
+          <a:p>
+            <a:pPr algn="l">
+              <a:spcAft>
+                <a:spcPts val="600"/>
+              </a:spcAft>
+            </a:pPr>
+            <a:r>
+              <a:rPr sz="1250" b="1" i="0">
+                <a:solidFill>
+                  <a:srgbClr val="D40511"/>
+                </a:solidFill>
+                <a:latin typeface="Calibri"/>
+              </a:rPr>
+              <a:t>WHAT I'M MOST PROUD OF</a:t>
+            </a:r>
           </a:p>
         </p:txBody>
       </p:sp>
@@ -9245,8 +9313,8 @@
         </p:nvSpPr>
         <p:spPr>
           <a:xfrm>
-            <a:off x="0" y="146304"/>
-            <a:ext cx="12191695" cy="38100"/>
+            <a:off x="640080" y="777240"/>
+            <a:ext cx="365760" cy="40640"/>
           </a:xfrm>
           <a:prstGeom prst="rect">
             <a:avLst/>
@@ -9289,8 +9357,8 @@
         </p:nvSpPr>
         <p:spPr>
           <a:xfrm>
-            <a:off x="731520" y="685800"/>
-            <a:ext cx="10058400" cy="457200"/>
+            <a:off x="640080" y="822960"/>
+            <a:ext cx="10881360" cy="914400"/>
           </a:xfrm>
           <a:prstGeom prst="rect">
             <a:avLst/>
@@ -9309,161 +9377,33 @@
               </a:spcAft>
             </a:pPr>
             <a:r>
-              <a:rPr sz="1300" b="1" i="0">
-                <a:solidFill>
-                  <a:srgbClr val="FFCC00"/>
-                </a:solidFill>
-                <a:latin typeface="Calibri"/>
-              </a:rPr>
-              <a:t>LOOKING AHEAD</a:t>
-            </a:r>
-          </a:p>
-        </p:txBody>
-      </p:sp>
-      <p:sp>
-        <p:nvSpPr>
-          <p:cNvPr id="6" name="TextBox 5"/>
-          <p:cNvSpPr txBox="1"/>
-          <p:nvPr/>
-        </p:nvSpPr>
-        <p:spPr>
-          <a:xfrm>
-            <a:off x="731520" y="1234440"/>
-            <a:ext cx="10698480" cy="914400"/>
-          </a:xfrm>
-          <a:prstGeom prst="rect">
-            <a:avLst/>
-          </a:prstGeom>
-          <a:noFill/>
-        </p:spPr>
-        <p:txBody>
-          <a:bodyPr wrap="square" anchor="t" lIns="0" rIns="0" tIns="0" bIns="0">
-            <a:spAutoFit/>
-          </a:bodyPr>
-          <a:lstStyle/>
-          <a:p>
-            <a:pPr algn="l">
-              <a:spcAft>
-                <a:spcPts val="600"/>
-              </a:spcAft>
-            </a:pPr>
-            <a:r>
-              <a:rPr sz="3000" b="1" i="0">
-                <a:solidFill>
-                  <a:srgbClr val="FFFFFF"/>
-                </a:solidFill>
-                <a:latin typeface="Calibri"/>
-              </a:rPr>
-              <a:t>I have genuinely loved being part of this team.</a:t>
-            </a:r>
-          </a:p>
-        </p:txBody>
-      </p:sp>
-      <p:sp>
-        <p:nvSpPr>
-          <p:cNvPr id="7" name="TextBox 6"/>
-          <p:cNvSpPr txBox="1"/>
-          <p:nvPr/>
-        </p:nvSpPr>
-        <p:spPr>
-          <a:xfrm>
-            <a:off x="731520" y="2468880"/>
-            <a:ext cx="10698480" cy="2926080"/>
-          </a:xfrm>
-          <a:prstGeom prst="rect">
-            <a:avLst/>
-          </a:prstGeom>
-          <a:noFill/>
-        </p:spPr>
-        <p:txBody>
-          <a:bodyPr wrap="square" anchor="t" lIns="0" rIns="0" tIns="0" bIns="0">
-            <a:spAutoFit/>
-          </a:bodyPr>
-          <a:lstStyle/>
-          <a:p>
-            <a:pPr algn="l">
-              <a:spcAft>
-                <a:spcPts val="1500"/>
-              </a:spcAft>
-            </a:pPr>
-            <a:r>
-              <a:rPr sz="1600" b="0" i="0">
-                <a:solidFill>
-                  <a:srgbClr val="E7EAED"/>
-                </a:solidFill>
-                <a:latin typeface="Calibri"/>
-              </a:rPr>
-              <a:t>•  Thank you for the trust, the patience, and the chance to work on real problems that matter to the team.</a:t>
-            </a:r>
-          </a:p>
-          <a:p>
-            <a:pPr algn="l">
-              <a:spcAft>
-                <a:spcPts val="1500"/>
-              </a:spcAft>
-            </a:pPr>
-            <a:r>
-              <a:rPr sz="1600" b="0" i="0">
-                <a:solidFill>
-                  <a:srgbClr val="E7EAED"/>
-                </a:solidFill>
-                <a:latin typeface="Calibri"/>
-              </a:rPr>
-              <a:t>•  I learned an enormous amount here, from the AR and collections side of the business to the tools that support it.</a:t>
-            </a:r>
-          </a:p>
-          <a:p>
-            <a:pPr algn="l">
-              <a:spcAft>
-                <a:spcPts val="1500"/>
-              </a:spcAft>
-            </a:pPr>
-            <a:r>
-              <a:rPr sz="1600" b="0" i="0">
-                <a:solidFill>
-                  <a:srgbClr val="E7EAED"/>
-                </a:solidFill>
-                <a:latin typeface="Calibri"/>
-              </a:rPr>
-              <a:t>•  I am proud of what we built together, and I know there is more I could contribute with more time.</a:t>
-            </a:r>
-          </a:p>
-          <a:p>
-            <a:pPr algn="l">
-              <a:spcAft>
-                <a:spcPts val="1500"/>
-              </a:spcAft>
-            </a:pPr>
-            <a:r>
-              <a:rPr sz="1600" b="0" i="0">
-                <a:solidFill>
-                  <a:srgbClr val="E7EAED"/>
-                </a:solidFill>
-                <a:latin typeface="Calibri"/>
-              </a:rPr>
-              <a:t>•  This internship confirmed my interest in finance, analytics, and automation.</a:t>
-            </a:r>
-          </a:p>
-        </p:txBody>
-      </p:sp>
-      <p:sp>
-        <p:nvSpPr>
-          <p:cNvPr id="8" name="Rounded Rectangle 7"/>
+              <a:rPr sz="2900" b="1" i="0">
+                <a:solidFill>
+                  <a:srgbClr val="1A1D21"/>
+                </a:solidFill>
+                <a:latin typeface="Calibri"/>
+              </a:rPr>
+              <a:t>A few things that meant the most to me</a:t>
+            </a:r>
+          </a:p>
+        </p:txBody>
+      </p:sp>
+      <p:sp>
+        <p:nvSpPr>
+          <p:cNvPr id="6" name="Rectangle 5"/>
           <p:cNvSpPr/>
           <p:nvPr/>
         </p:nvSpPr>
         <p:spPr>
           <a:xfrm>
-            <a:off x="731520" y="5532120"/>
-            <a:ext cx="10698480" cy="777240"/>
-          </a:xfrm>
-          <a:prstGeom prst="roundRect">
-            <a:avLst>
-              <a:gd name="adj" fmla="val 12000"/>
-            </a:avLst>
+            <a:off x="640080" y="1938528"/>
+            <a:ext cx="10881360" cy="17780"/>
+          </a:xfrm>
+          <a:prstGeom prst="rect">
+            <a:avLst/>
           </a:prstGeom>
           <a:solidFill>
-            <a:srgbClr val="D40511"/>
+            <a:srgbClr val="E2E0DA"/>
           </a:solidFill>
           <a:ln>
             <a:noFill/>
@@ -9494,14 +9434,156 @@
       </p:sp>
       <p:sp>
         <p:nvSpPr>
+          <p:cNvPr id="7" name="TextBox 6"/>
+          <p:cNvSpPr txBox="1"/>
+          <p:nvPr/>
+        </p:nvSpPr>
+        <p:spPr>
+          <a:xfrm>
+            <a:off x="640080" y="2286000"/>
+            <a:ext cx="10881360" cy="4023360"/>
+          </a:xfrm>
+          <a:prstGeom prst="rect">
+            <a:avLst/>
+          </a:prstGeom>
+          <a:noFill/>
+        </p:spPr>
+        <p:txBody>
+          <a:bodyPr wrap="square" anchor="t" lIns="0" rIns="0" tIns="0" bIns="0">
+            <a:spAutoFit/>
+          </a:bodyPr>
+          <a:lstStyle/>
+          <a:p>
+            <a:pPr algn="l">
+              <a:spcAft>
+                <a:spcPts val="1300"/>
+              </a:spcAft>
+            </a:pPr>
+            <a:r>
+              <a:rPr sz="1550" b="0" i="0">
+                <a:solidFill>
+                  <a:srgbClr val="1A1D21"/>
+                </a:solidFill>
+                <a:latin typeface="Calibri"/>
+              </a:rPr>
+              <a:t>•  Building three automation solutions that are genuinely in use, not just prototypes.</a:t>
+            </a:r>
+          </a:p>
+          <a:p>
+            <a:pPr algn="l">
+              <a:spcAft>
+                <a:spcPts val="1300"/>
+              </a:spcAft>
+            </a:pPr>
+            <a:r>
+              <a:rPr sz="1550" b="0" i="0">
+                <a:solidFill>
+                  <a:srgbClr val="1A1D21"/>
+                </a:solidFill>
+                <a:latin typeface="Calibri"/>
+              </a:rPr>
+              <a:t>•  Taking real, repetitive reporting effort off the team's plate each day.</a:t>
+            </a:r>
+          </a:p>
+          <a:p>
+            <a:pPr algn="l">
+              <a:spcAft>
+                <a:spcPts val="1300"/>
+              </a:spcAft>
+            </a:pPr>
+            <a:r>
+              <a:rPr sz="1550" b="0" i="0">
+                <a:solidFill>
+                  <a:srgbClr val="1A1D21"/>
+                </a:solidFill>
+                <a:latin typeface="Calibri"/>
+              </a:rPr>
+              <a:t>•  Creating reusable frameworks that can grow, rather than one-time fixes.</a:t>
+            </a:r>
+          </a:p>
+          <a:p>
+            <a:pPr algn="l">
+              <a:spcAft>
+                <a:spcPts val="1300"/>
+              </a:spcAft>
+            </a:pPr>
+            <a:r>
+              <a:rPr sz="1550" b="0" i="0">
+                <a:solidFill>
+                  <a:srgbClr val="1A1D21"/>
+                </a:solidFill>
+                <a:latin typeface="Calibri"/>
+              </a:rPr>
+              <a:t>•  Leaving behind solutions that keep running after the internship ends.</a:t>
+            </a:r>
+          </a:p>
+          <a:p>
+            <a:pPr algn="l">
+              <a:spcAft>
+                <a:spcPts val="1300"/>
+              </a:spcAft>
+            </a:pPr>
+            <a:r>
+              <a:rPr sz="1550" b="0" i="0">
+                <a:solidFill>
+                  <a:srgbClr val="1A1D21"/>
+                </a:solidFill>
+                <a:latin typeface="Calibri"/>
+              </a:rPr>
+              <a:t>•  Giving the team clearer visibility into AR performance and collections activity.</a:t>
+            </a:r>
+          </a:p>
+        </p:txBody>
+      </p:sp>
+      <p:sp>
+        <p:nvSpPr>
+          <p:cNvPr id="8" name="TextBox 7"/>
+          <p:cNvSpPr txBox="1"/>
+          <p:nvPr/>
+        </p:nvSpPr>
+        <p:spPr>
+          <a:xfrm>
+            <a:off x="640080" y="6537960"/>
+            <a:ext cx="8229600" cy="274320"/>
+          </a:xfrm>
+          <a:prstGeom prst="rect">
+            <a:avLst/>
+          </a:prstGeom>
+          <a:noFill/>
+        </p:spPr>
+        <p:txBody>
+          <a:bodyPr wrap="square" anchor="t" lIns="0" rIns="0" tIns="0" bIns="0">
+            <a:spAutoFit/>
+          </a:bodyPr>
+          <a:lstStyle/>
+          <a:p>
+            <a:pPr algn="l">
+              <a:spcAft>
+                <a:spcPts val="600"/>
+              </a:spcAft>
+            </a:pPr>
+            <a:r>
+              <a:rPr sz="900" b="0" i="0">
+                <a:solidFill>
+                  <a:srgbClr val="8A837B"/>
+                </a:solidFill>
+                <a:latin typeface="Calibri"/>
+              </a:rPr>
+              <a:t>AMKAD  ·  AR Reporting &amp; Collections Automation  ·  Internship Close-Out</a:t>
+            </a:r>
+          </a:p>
+        </p:txBody>
+      </p:sp>
+      <p:sp>
+        <p:nvSpPr>
           <p:cNvPr id="9" name="TextBox 8"/>
           <p:cNvSpPr txBox="1"/>
           <p:nvPr/>
         </p:nvSpPr>
         <p:spPr>
           <a:xfrm>
-            <a:off x="1005840" y="5614416"/>
-            <a:ext cx="10149840" cy="594360"/>
+            <a:off x="11247120" y="6537960"/>
+            <a:ext cx="640080" cy="274320"/>
           </a:xfrm>
           <a:prstGeom prst="rect">
             <a:avLst/>
@@ -9509,24 +9591,24 @@
           <a:noFill/>
         </p:spPr>
         <p:txBody>
-          <a:bodyPr wrap="square" anchor="ctr" lIns="0" rIns="0" tIns="0" bIns="0">
+          <a:bodyPr wrap="square" anchor="t" lIns="0" rIns="0" tIns="0" bIns="0">
             <a:spAutoFit/>
           </a:bodyPr>
           <a:lstStyle/>
           <a:p>
-            <a:pPr algn="l">
+            <a:pPr algn="r">
               <a:spcAft>
                 <a:spcPts val="600"/>
               </a:spcAft>
             </a:pPr>
             <a:r>
-              <a:rPr sz="1500" b="1" i="0">
-                <a:solidFill>
-                  <a:srgbClr val="FFFFFF"/>
-                </a:solidFill>
-                <a:latin typeface="Calibri"/>
-              </a:rPr>
-              <a:t>I am grateful for the opportunity to contribute to AMKAD, and would be excited to keep building solutions like these in the future.</a:t>
+              <a:rPr sz="900" b="0" i="0">
+                <a:solidFill>
+                  <a:srgbClr val="8A837B"/>
+                </a:solidFill>
+                <a:latin typeface="Calibri"/>
+              </a:rPr>
+              <a:t>17</a:t>
             </a:r>
           </a:p>
         </p:txBody>
@@ -9595,14 +9677,407 @@
       </p:sp>
       <p:sp>
         <p:nvSpPr>
+          <p:cNvPr id="3" name="TextBox 2"/>
+          <p:cNvSpPr txBox="1"/>
+          <p:nvPr/>
+        </p:nvSpPr>
+        <p:spPr>
+          <a:xfrm>
+            <a:off x="640080" y="457200"/>
+            <a:ext cx="10058400" cy="365760"/>
+          </a:xfrm>
+          <a:prstGeom prst="rect">
+            <a:avLst/>
+          </a:prstGeom>
+          <a:noFill/>
+        </p:spPr>
+        <p:txBody>
+          <a:bodyPr wrap="square" anchor="t" lIns="0" rIns="0" tIns="0" bIns="0">
+            <a:spAutoFit/>
+          </a:bodyPr>
+          <a:lstStyle/>
+          <a:p>
+            <a:pPr algn="l">
+              <a:spcAft>
+                <a:spcPts val="600"/>
+              </a:spcAft>
+            </a:pPr>
+            <a:r>
+              <a:rPr sz="1250" b="1" i="0">
+                <a:solidFill>
+                  <a:srgbClr val="D40511"/>
+                </a:solidFill>
+                <a:latin typeface="Calibri"/>
+              </a:rPr>
+              <a:t>WHAT'S NEXT</a:t>
+            </a:r>
+          </a:p>
+        </p:txBody>
+      </p:sp>
+      <p:sp>
+        <p:nvSpPr>
+          <p:cNvPr id="4" name="Rectangle 3"/>
+          <p:cNvSpPr/>
+          <p:nvPr/>
+        </p:nvSpPr>
+        <p:spPr>
+          <a:xfrm>
+            <a:off x="640080" y="777240"/>
+            <a:ext cx="365760" cy="40640"/>
+          </a:xfrm>
+          <a:prstGeom prst="rect">
+            <a:avLst/>
+          </a:prstGeom>
+          <a:solidFill>
+            <a:srgbClr val="FFCC00"/>
+          </a:solidFill>
+          <a:ln>
+            <a:noFill/>
+          </a:ln>
+          <a:effectLst/>
+        </p:spPr>
+        <p:style>
+          <a:lnRef idx="1">
+            <a:schemeClr val="accent1"/>
+          </a:lnRef>
+          <a:fillRef idx="3">
+            <a:schemeClr val="accent1"/>
+          </a:fillRef>
+          <a:effectRef idx="2">
+            <a:schemeClr val="accent1"/>
+          </a:effectRef>
+          <a:fontRef idx="minor">
+            <a:schemeClr val="lt1"/>
+          </a:fontRef>
+        </p:style>
+        <p:txBody>
+          <a:bodyPr rtlCol="0" anchor="ctr"/>
+          <a:lstStyle/>
+          <a:p>
+            <a:pPr algn="ctr"/>
+          </a:p>
+        </p:txBody>
+      </p:sp>
+      <p:sp>
+        <p:nvSpPr>
+          <p:cNvPr id="5" name="TextBox 4"/>
+          <p:cNvSpPr txBox="1"/>
+          <p:nvPr/>
+        </p:nvSpPr>
+        <p:spPr>
+          <a:xfrm>
+            <a:off x="640080" y="822960"/>
+            <a:ext cx="10881360" cy="914400"/>
+          </a:xfrm>
+          <a:prstGeom prst="rect">
+            <a:avLst/>
+          </a:prstGeom>
+          <a:noFill/>
+        </p:spPr>
+        <p:txBody>
+          <a:bodyPr wrap="square" anchor="t" lIns="0" rIns="0" tIns="0" bIns="0">
+            <a:spAutoFit/>
+          </a:bodyPr>
+          <a:lstStyle/>
+          <a:p>
+            <a:pPr algn="l">
+              <a:spcAft>
+                <a:spcPts val="600"/>
+              </a:spcAft>
+            </a:pPr>
+            <a:r>
+              <a:rPr sz="2900" b="1" i="0">
+                <a:solidFill>
+                  <a:srgbClr val="1A1D21"/>
+                </a:solidFill>
+                <a:latin typeface="Calibri"/>
+              </a:rPr>
+              <a:t>How this can grow from here</a:t>
+            </a:r>
+          </a:p>
+        </p:txBody>
+      </p:sp>
+      <p:sp>
+        <p:nvSpPr>
+          <p:cNvPr id="6" name="Rectangle 5"/>
+          <p:cNvSpPr/>
+          <p:nvPr/>
+        </p:nvSpPr>
+        <p:spPr>
+          <a:xfrm>
+            <a:off x="640080" y="1938528"/>
+            <a:ext cx="10881360" cy="17780"/>
+          </a:xfrm>
+          <a:prstGeom prst="rect">
+            <a:avLst/>
+          </a:prstGeom>
+          <a:solidFill>
+            <a:srgbClr val="E2E0DA"/>
+          </a:solidFill>
+          <a:ln>
+            <a:noFill/>
+          </a:ln>
+          <a:effectLst/>
+        </p:spPr>
+        <p:style>
+          <a:lnRef idx="1">
+            <a:schemeClr val="accent1"/>
+          </a:lnRef>
+          <a:fillRef idx="3">
+            <a:schemeClr val="accent1"/>
+          </a:fillRef>
+          <a:effectRef idx="2">
+            <a:schemeClr val="accent1"/>
+          </a:effectRef>
+          <a:fontRef idx="minor">
+            <a:schemeClr val="lt1"/>
+          </a:fontRef>
+        </p:style>
+        <p:txBody>
+          <a:bodyPr rtlCol="0" anchor="ctr"/>
+          <a:lstStyle/>
+          <a:p>
+            <a:pPr algn="ctr"/>
+          </a:p>
+        </p:txBody>
+      </p:sp>
+      <p:sp>
+        <p:nvSpPr>
+          <p:cNvPr id="7" name="TextBox 6"/>
+          <p:cNvSpPr txBox="1"/>
+          <p:nvPr/>
+        </p:nvSpPr>
+        <p:spPr>
+          <a:xfrm>
+            <a:off x="640080" y="2286000"/>
+            <a:ext cx="10881360" cy="4023360"/>
+          </a:xfrm>
+          <a:prstGeom prst="rect">
+            <a:avLst/>
+          </a:prstGeom>
+          <a:noFill/>
+        </p:spPr>
+        <p:txBody>
+          <a:bodyPr wrap="square" anchor="t" lIns="0" rIns="0" tIns="0" bIns="0">
+            <a:spAutoFit/>
+          </a:bodyPr>
+          <a:lstStyle/>
+          <a:p>
+            <a:pPr algn="l">
+              <a:spcAft>
+                <a:spcPts val="1300"/>
+              </a:spcAft>
+            </a:pPr>
+            <a:r>
+              <a:rPr sz="1550" b="0" i="0">
+                <a:solidFill>
+                  <a:srgbClr val="1A1D21"/>
+                </a:solidFill>
+                <a:latin typeface="Calibri"/>
+              </a:rPr>
+              <a:t>•  Extend the SOA framework to more customers and countries, since the reusable engine is already in place.</a:t>
+            </a:r>
+          </a:p>
+          <a:p>
+            <a:pPr algn="l">
+              <a:spcAft>
+                <a:spcPts val="1300"/>
+              </a:spcAft>
+            </a:pPr>
+            <a:r>
+              <a:rPr sz="1550" b="0" i="0">
+                <a:solidFill>
+                  <a:srgbClr val="1A1D21"/>
+                </a:solidFill>
+                <a:latin typeface="Calibri"/>
+              </a:rPr>
+              <a:t>•  Move the data layer toward a centralized database (SQL and Data Factory), which would be a stronger backbone for everything above.</a:t>
+            </a:r>
+          </a:p>
+          <a:p>
+            <a:pPr algn="l">
+              <a:spcAft>
+                <a:spcPts val="1300"/>
+              </a:spcAft>
+            </a:pPr>
+            <a:r>
+              <a:rPr sz="1550" b="0" i="0">
+                <a:solidFill>
+                  <a:srgbClr val="1A1D21"/>
+                </a:solidFill>
+                <a:latin typeface="Calibri"/>
+              </a:rPr>
+              <a:t>•  Build leadership-facing Power BI dashboards on top of the same consolidated data.</a:t>
+            </a:r>
+          </a:p>
+          <a:p>
+            <a:pPr algn="l">
+              <a:spcAft>
+                <a:spcPts val="1300"/>
+              </a:spcAft>
+            </a:pPr>
+            <a:r>
+              <a:rPr sz="1550" b="0" i="0">
+                <a:solidFill>
+                  <a:srgbClr val="1A1D21"/>
+                </a:solidFill>
+                <a:latin typeface="Calibri"/>
+              </a:rPr>
+              <a:t>•  Small hardening steps, like standardizing the monthly folder names and adding alerts for missing or late source files.</a:t>
+            </a:r>
+          </a:p>
+        </p:txBody>
+      </p:sp>
+      <p:sp>
+        <p:nvSpPr>
+          <p:cNvPr id="8" name="TextBox 7"/>
+          <p:cNvSpPr txBox="1"/>
+          <p:nvPr/>
+        </p:nvSpPr>
+        <p:spPr>
+          <a:xfrm>
+            <a:off x="640080" y="6537960"/>
+            <a:ext cx="8229600" cy="274320"/>
+          </a:xfrm>
+          <a:prstGeom prst="rect">
+            <a:avLst/>
+          </a:prstGeom>
+          <a:noFill/>
+        </p:spPr>
+        <p:txBody>
+          <a:bodyPr wrap="square" anchor="t" lIns="0" rIns="0" tIns="0" bIns="0">
+            <a:spAutoFit/>
+          </a:bodyPr>
+          <a:lstStyle/>
+          <a:p>
+            <a:pPr algn="l">
+              <a:spcAft>
+                <a:spcPts val="600"/>
+              </a:spcAft>
+            </a:pPr>
+            <a:r>
+              <a:rPr sz="900" b="0" i="0">
+                <a:solidFill>
+                  <a:srgbClr val="8A837B"/>
+                </a:solidFill>
+                <a:latin typeface="Calibri"/>
+              </a:rPr>
+              <a:t>AMKAD  ·  AR Reporting &amp; Collections Automation  ·  Internship Close-Out</a:t>
+            </a:r>
+          </a:p>
+        </p:txBody>
+      </p:sp>
+      <p:sp>
+        <p:nvSpPr>
+          <p:cNvPr id="9" name="TextBox 8"/>
+          <p:cNvSpPr txBox="1"/>
+          <p:nvPr/>
+        </p:nvSpPr>
+        <p:spPr>
+          <a:xfrm>
+            <a:off x="11247120" y="6537960"/>
+            <a:ext cx="640080" cy="274320"/>
+          </a:xfrm>
+          <a:prstGeom prst="rect">
+            <a:avLst/>
+          </a:prstGeom>
+          <a:noFill/>
+        </p:spPr>
+        <p:txBody>
+          <a:bodyPr wrap="square" anchor="t" lIns="0" rIns="0" tIns="0" bIns="0">
+            <a:spAutoFit/>
+          </a:bodyPr>
+          <a:lstStyle/>
+          <a:p>
+            <a:pPr algn="r">
+              <a:spcAft>
+                <a:spcPts val="600"/>
+              </a:spcAft>
+            </a:pPr>
+            <a:r>
+              <a:rPr sz="900" b="0" i="0">
+                <a:solidFill>
+                  <a:srgbClr val="8A837B"/>
+                </a:solidFill>
+                <a:latin typeface="Calibri"/>
+              </a:rPr>
+              <a:t>18</a:t>
+            </a:r>
+          </a:p>
+        </p:txBody>
+      </p:sp>
+    </p:spTree>
+  </p:cSld>
+  <p:clrMapOvr>
+    <a:masterClrMapping/>
+  </p:clrMapOvr>
+</p:sld>
+</file>
+
+<file path=ppt/slides/slide19.xml><?xml version="1.0" encoding="utf-8"?>
+<p:sld xmlns:a="http://schemas.openxmlformats.org/drawingml/2006/main" xmlns:p="http://schemas.openxmlformats.org/presentationml/2006/main" xmlns:r="http://schemas.openxmlformats.org/officeDocument/2006/relationships">
+  <p:cSld>
+    <p:spTree>
+      <p:nvGrpSpPr>
+        <p:cNvPr id="1" name=""/>
+        <p:cNvGrpSpPr/>
+        <p:nvPr/>
+      </p:nvGrpSpPr>
+      <p:grpSpPr/>
+      <p:sp>
+        <p:nvSpPr>
+          <p:cNvPr id="2" name="Rectangle 1"/>
+          <p:cNvSpPr/>
+          <p:nvPr/>
+        </p:nvSpPr>
+        <p:spPr>
+          <a:xfrm>
+            <a:off x="0" y="0"/>
+            <a:ext cx="12191695" cy="6858000"/>
+          </a:xfrm>
+          <a:prstGeom prst="rect">
+            <a:avLst/>
+          </a:prstGeom>
+          <a:solidFill>
+            <a:srgbClr val="1A1D21"/>
+          </a:solidFill>
+          <a:ln>
+            <a:noFill/>
+          </a:ln>
+          <a:effectLst/>
+        </p:spPr>
+        <p:style>
+          <a:lnRef idx="1">
+            <a:schemeClr val="accent1"/>
+          </a:lnRef>
+          <a:fillRef idx="3">
+            <a:schemeClr val="accent1"/>
+          </a:fillRef>
+          <a:effectRef idx="2">
+            <a:schemeClr val="accent1"/>
+          </a:effectRef>
+          <a:fontRef idx="minor">
+            <a:schemeClr val="lt1"/>
+          </a:fontRef>
+        </p:style>
+        <p:txBody>
+          <a:bodyPr rtlCol="0" anchor="ctr"/>
+          <a:lstStyle/>
+          <a:p>
+            <a:pPr algn="ctr"/>
+          </a:p>
+        </p:txBody>
+      </p:sp>
+      <p:sp>
+        <p:nvSpPr>
           <p:cNvPr id="3" name="Rectangle 2"/>
           <p:cNvSpPr/>
           <p:nvPr/>
         </p:nvSpPr>
         <p:spPr>
           <a:xfrm>
-            <a:off x="0" y="3200400"/>
-            <a:ext cx="12191695" cy="38100"/>
+            <a:off x="0" y="0"/>
+            <a:ext cx="12191695" cy="146304"/>
           </a:xfrm>
           <a:prstGeom prst="rect">
             <a:avLst/>
@@ -9639,138 +10114,23 @@
       </p:sp>
       <p:sp>
         <p:nvSpPr>
-          <p:cNvPr id="4" name="TextBox 3"/>
-          <p:cNvSpPr txBox="1"/>
-          <p:nvPr/>
-        </p:nvSpPr>
-        <p:spPr>
-          <a:xfrm>
-            <a:off x="731520" y="2286000"/>
-            <a:ext cx="10698480" cy="914400"/>
-          </a:xfrm>
-          <a:prstGeom prst="rect">
-            <a:avLst/>
-          </a:prstGeom>
-          <a:noFill/>
-        </p:spPr>
-        <p:txBody>
-          <a:bodyPr wrap="square" anchor="b" lIns="0" rIns="0" tIns="0" bIns="0">
-            <a:spAutoFit/>
-          </a:bodyPr>
-          <a:lstStyle/>
-          <a:p>
-            <a:pPr algn="l">
-              <a:spcAft>
-                <a:spcPts val="600"/>
-              </a:spcAft>
-            </a:pPr>
-            <a:r>
-              <a:rPr sz="4000" b="1" i="0">
-                <a:solidFill>
-                  <a:srgbClr val="1A1D21"/>
-                </a:solidFill>
-                <a:latin typeface="Calibri"/>
-              </a:rPr>
-              <a:t>Thank you</a:t>
-            </a:r>
-          </a:p>
-        </p:txBody>
-      </p:sp>
-      <p:sp>
-        <p:nvSpPr>
-          <p:cNvPr id="5" name="TextBox 4"/>
-          <p:cNvSpPr txBox="1"/>
-          <p:nvPr/>
-        </p:nvSpPr>
-        <p:spPr>
-          <a:xfrm>
-            <a:off x="731520" y="3429000"/>
-            <a:ext cx="10698480" cy="1097280"/>
-          </a:xfrm>
-          <a:prstGeom prst="rect">
-            <a:avLst/>
-          </a:prstGeom>
-          <a:noFill/>
-        </p:spPr>
-        <p:txBody>
-          <a:bodyPr wrap="square" anchor="t" lIns="0" rIns="0" tIns="0" bIns="0">
-            <a:spAutoFit/>
-          </a:bodyPr>
-          <a:lstStyle/>
-          <a:p>
-            <a:pPr algn="l">
-              <a:spcAft>
-                <a:spcPts val="300"/>
-              </a:spcAft>
-            </a:pPr>
-            <a:r>
-              <a:rPr sz="1800" b="1" i="0">
-                <a:solidFill>
-                  <a:srgbClr val="1A1D21"/>
-                </a:solidFill>
-                <a:latin typeface="Calibri"/>
-              </a:rPr>
-              <a:t>Jean Kadadihi</a:t>
-            </a:r>
-          </a:p>
-          <a:p>
-            <a:pPr algn="l">
-              <a:spcAft>
-                <a:spcPts val="200"/>
-              </a:spcAft>
-            </a:pPr>
-            <a:r>
-              <a:rPr sz="1350" b="0" i="0">
-                <a:solidFill>
-                  <a:srgbClr val="5B6470"/>
-                </a:solidFill>
-                <a:latin typeface="Calibri"/>
-              </a:rPr>
-              <a:t>Finance Intern, Controlling  ·  DHL Express Americas, Key Account Desk (AMKAD)</a:t>
-            </a:r>
-          </a:p>
-          <a:p>
-            <a:pPr algn="l">
-              <a:spcAft>
-                <a:spcPts val="600"/>
-              </a:spcAft>
-            </a:pPr>
-            <a:r>
-              <a:rPr sz="1350" b="0" i="1">
-                <a:solidFill>
-                  <a:srgbClr val="A5040D"/>
-                </a:solidFill>
-                <a:latin typeface="Calibri"/>
-              </a:rPr>
-              <a:t>I would be happy to answer any questions.</a:t>
-            </a:r>
-          </a:p>
-        </p:txBody>
-      </p:sp>
-      <p:sp>
-        <p:nvSpPr>
-          <p:cNvPr id="6" name="Rounded Rectangle 5"/>
+          <p:cNvPr id="4" name="Rectangle 3"/>
           <p:cNvSpPr/>
           <p:nvPr/>
         </p:nvSpPr>
         <p:spPr>
           <a:xfrm>
-            <a:off x="9966960" y="548640"/>
-            <a:ext cx="1737360" cy="685800"/>
-          </a:xfrm>
-          <a:prstGeom prst="roundRect">
-            <a:avLst>
-              <a:gd name="adj" fmla="val 8000"/>
-            </a:avLst>
+            <a:off x="0" y="146304"/>
+            <a:ext cx="12191695" cy="38100"/>
+          </a:xfrm>
+          <a:prstGeom prst="rect">
+            <a:avLst/>
           </a:prstGeom>
           <a:solidFill>
-            <a:srgbClr val="FFFFFF"/>
+            <a:srgbClr val="FFCC00"/>
           </a:solidFill>
-          <a:ln w="9525">
-            <a:solidFill>
-              <a:srgbClr val="8A837B"/>
-            </a:solidFill>
-            <a:prstDash val="dash"/>
+          <a:ln>
+            <a:noFill/>
           </a:ln>
           <a:effectLst/>
         </p:spPr>
@@ -9798,14 +10158,225 @@
       </p:sp>
       <p:sp>
         <p:nvSpPr>
+          <p:cNvPr id="5" name="TextBox 4"/>
+          <p:cNvSpPr txBox="1"/>
+          <p:nvPr/>
+        </p:nvSpPr>
+        <p:spPr>
+          <a:xfrm>
+            <a:off x="731520" y="685800"/>
+            <a:ext cx="10058400" cy="457200"/>
+          </a:xfrm>
+          <a:prstGeom prst="rect">
+            <a:avLst/>
+          </a:prstGeom>
+          <a:noFill/>
+        </p:spPr>
+        <p:txBody>
+          <a:bodyPr wrap="square" anchor="t" lIns="0" rIns="0" tIns="0" bIns="0">
+            <a:spAutoFit/>
+          </a:bodyPr>
+          <a:lstStyle/>
+          <a:p>
+            <a:pPr algn="l">
+              <a:spcAft>
+                <a:spcPts val="600"/>
+              </a:spcAft>
+            </a:pPr>
+            <a:r>
+              <a:rPr sz="1300" b="1" i="0">
+                <a:solidFill>
+                  <a:srgbClr val="FFCC00"/>
+                </a:solidFill>
+                <a:latin typeface="Calibri"/>
+              </a:rPr>
+              <a:t>LOOKING AHEAD</a:t>
+            </a:r>
+          </a:p>
+        </p:txBody>
+      </p:sp>
+      <p:sp>
+        <p:nvSpPr>
+          <p:cNvPr id="6" name="TextBox 5"/>
+          <p:cNvSpPr txBox="1"/>
+          <p:nvPr/>
+        </p:nvSpPr>
+        <p:spPr>
+          <a:xfrm>
+            <a:off x="731520" y="1234440"/>
+            <a:ext cx="10698480" cy="914400"/>
+          </a:xfrm>
+          <a:prstGeom prst="rect">
+            <a:avLst/>
+          </a:prstGeom>
+          <a:noFill/>
+        </p:spPr>
+        <p:txBody>
+          <a:bodyPr wrap="square" anchor="t" lIns="0" rIns="0" tIns="0" bIns="0">
+            <a:spAutoFit/>
+          </a:bodyPr>
+          <a:lstStyle/>
+          <a:p>
+            <a:pPr algn="l">
+              <a:spcAft>
+                <a:spcPts val="600"/>
+              </a:spcAft>
+            </a:pPr>
+            <a:r>
+              <a:rPr sz="3000" b="1" i="0">
+                <a:solidFill>
+                  <a:srgbClr val="FFFFFF"/>
+                </a:solidFill>
+                <a:latin typeface="Calibri"/>
+              </a:rPr>
+              <a:t>I have genuinely loved being part of this team.</a:t>
+            </a:r>
+          </a:p>
+        </p:txBody>
+      </p:sp>
+      <p:sp>
+        <p:nvSpPr>
           <p:cNvPr id="7" name="TextBox 6"/>
           <p:cNvSpPr txBox="1"/>
           <p:nvPr/>
         </p:nvSpPr>
         <p:spPr>
           <a:xfrm>
-            <a:off x="9966960" y="548640"/>
-            <a:ext cx="1737360" cy="685800"/>
+            <a:off x="731520" y="2468880"/>
+            <a:ext cx="10698480" cy="2926080"/>
+          </a:xfrm>
+          <a:prstGeom prst="rect">
+            <a:avLst/>
+          </a:prstGeom>
+          <a:noFill/>
+        </p:spPr>
+        <p:txBody>
+          <a:bodyPr wrap="square" anchor="t" lIns="0" rIns="0" tIns="0" bIns="0">
+            <a:spAutoFit/>
+          </a:bodyPr>
+          <a:lstStyle/>
+          <a:p>
+            <a:pPr algn="l">
+              <a:spcAft>
+                <a:spcPts val="1500"/>
+              </a:spcAft>
+            </a:pPr>
+            <a:r>
+              <a:rPr sz="1600" b="0" i="0">
+                <a:solidFill>
+                  <a:srgbClr val="E7EAED"/>
+                </a:solidFill>
+                <a:latin typeface="Calibri"/>
+              </a:rPr>
+              <a:t>•  Thank you for the trust, the patience, and the chance to work on real problems that matter to the team.</a:t>
+            </a:r>
+          </a:p>
+          <a:p>
+            <a:pPr algn="l">
+              <a:spcAft>
+                <a:spcPts val="1500"/>
+              </a:spcAft>
+            </a:pPr>
+            <a:r>
+              <a:rPr sz="1600" b="0" i="0">
+                <a:solidFill>
+                  <a:srgbClr val="E7EAED"/>
+                </a:solidFill>
+                <a:latin typeface="Calibri"/>
+              </a:rPr>
+              <a:t>•  I learned an enormous amount here, from the AR and collections side of the business to the tools that support it.</a:t>
+            </a:r>
+          </a:p>
+          <a:p>
+            <a:pPr algn="l">
+              <a:spcAft>
+                <a:spcPts val="1500"/>
+              </a:spcAft>
+            </a:pPr>
+            <a:r>
+              <a:rPr sz="1600" b="0" i="0">
+                <a:solidFill>
+                  <a:srgbClr val="E7EAED"/>
+                </a:solidFill>
+                <a:latin typeface="Calibri"/>
+              </a:rPr>
+              <a:t>•  I am proud of what we built together, and I know there is more I could contribute with more time.</a:t>
+            </a:r>
+          </a:p>
+          <a:p>
+            <a:pPr algn="l">
+              <a:spcAft>
+                <a:spcPts val="1500"/>
+              </a:spcAft>
+            </a:pPr>
+            <a:r>
+              <a:rPr sz="1600" b="0" i="0">
+                <a:solidFill>
+                  <a:srgbClr val="E7EAED"/>
+                </a:solidFill>
+                <a:latin typeface="Calibri"/>
+              </a:rPr>
+              <a:t>•  This internship confirmed my interest in finance, analytics, and automation.</a:t>
+            </a:r>
+          </a:p>
+        </p:txBody>
+      </p:sp>
+      <p:sp>
+        <p:nvSpPr>
+          <p:cNvPr id="8" name="Rounded Rectangle 7"/>
+          <p:cNvSpPr/>
+          <p:nvPr/>
+        </p:nvSpPr>
+        <p:spPr>
+          <a:xfrm>
+            <a:off x="731520" y="5532120"/>
+            <a:ext cx="10698480" cy="777240"/>
+          </a:xfrm>
+          <a:prstGeom prst="roundRect">
+            <a:avLst>
+              <a:gd name="adj" fmla="val 12000"/>
+            </a:avLst>
+          </a:prstGeom>
+          <a:solidFill>
+            <a:srgbClr val="D40511"/>
+          </a:solidFill>
+          <a:ln>
+            <a:noFill/>
+          </a:ln>
+          <a:effectLst/>
+        </p:spPr>
+        <p:style>
+          <a:lnRef idx="1">
+            <a:schemeClr val="accent1"/>
+          </a:lnRef>
+          <a:fillRef idx="3">
+            <a:schemeClr val="accent1"/>
+          </a:fillRef>
+          <a:effectRef idx="2">
+            <a:schemeClr val="accent1"/>
+          </a:effectRef>
+          <a:fontRef idx="minor">
+            <a:schemeClr val="lt1"/>
+          </a:fontRef>
+        </p:style>
+        <p:txBody>
+          <a:bodyPr rtlCol="0" anchor="ctr"/>
+          <a:lstStyle/>
+          <a:p>
+            <a:pPr algn="ctr"/>
+          </a:p>
+        </p:txBody>
+      </p:sp>
+      <p:sp>
+        <p:nvSpPr>
+          <p:cNvPr id="9" name="TextBox 8"/>
+          <p:cNvSpPr txBox="1"/>
+          <p:nvPr/>
+        </p:nvSpPr>
+        <p:spPr>
+          <a:xfrm>
+            <a:off x="1005840" y="5614416"/>
+            <a:ext cx="10149840" cy="594360"/>
           </a:xfrm>
           <a:prstGeom prst="rect">
             <a:avLst/>
@@ -9818,19 +10389,19 @@
           </a:bodyPr>
           <a:lstStyle/>
           <a:p>
-            <a:pPr algn="ctr">
+            <a:pPr algn="l">
               <a:spcAft>
                 <a:spcPts val="600"/>
               </a:spcAft>
             </a:pPr>
             <a:r>
-              <a:rPr sz="900" b="0" i="1">
-                <a:solidFill>
-                  <a:srgbClr val="8A837B"/>
-                </a:solidFill>
-                <a:latin typeface="Calibri"/>
-              </a:rPr>
-              <a:t>paste DHL logo</a:t>
+              <a:rPr sz="1500" b="1" i="0">
+                <a:solidFill>
+                  <a:srgbClr val="FFFFFF"/>
+                </a:solidFill>
+                <a:latin typeface="Calibri"/>
+              </a:rPr>
+              <a:t>I am grateful for the opportunity to contribute to AMKAD, and would be excited to keep building solutions like these in the future.</a:t>
             </a:r>
           </a:p>
         </p:txBody>
@@ -10688,6 +11259,310 @@
                 <a:latin typeface="Calibri"/>
               </a:rPr>
               <a:t>2</a:t>
+            </a:r>
+          </a:p>
+        </p:txBody>
+      </p:sp>
+    </p:spTree>
+  </p:cSld>
+  <p:clrMapOvr>
+    <a:masterClrMapping/>
+  </p:clrMapOvr>
+</p:sld>
+</file>
+
+<file path=ppt/slides/slide20.xml><?xml version="1.0" encoding="utf-8"?>
+<p:sld xmlns:a="http://schemas.openxmlformats.org/drawingml/2006/main" xmlns:p="http://schemas.openxmlformats.org/presentationml/2006/main" xmlns:r="http://schemas.openxmlformats.org/officeDocument/2006/relationships">
+  <p:cSld>
+    <p:spTree>
+      <p:nvGrpSpPr>
+        <p:cNvPr id="1" name=""/>
+        <p:cNvGrpSpPr/>
+        <p:nvPr/>
+      </p:nvGrpSpPr>
+      <p:grpSpPr/>
+      <p:sp>
+        <p:nvSpPr>
+          <p:cNvPr id="2" name="Rectangle 1"/>
+          <p:cNvSpPr/>
+          <p:nvPr/>
+        </p:nvSpPr>
+        <p:spPr>
+          <a:xfrm>
+            <a:off x="0" y="0"/>
+            <a:ext cx="12191695" cy="6858000"/>
+          </a:xfrm>
+          <a:prstGeom prst="rect">
+            <a:avLst/>
+          </a:prstGeom>
+          <a:solidFill>
+            <a:srgbClr val="F7F6F3"/>
+          </a:solidFill>
+          <a:ln>
+            <a:noFill/>
+          </a:ln>
+          <a:effectLst/>
+        </p:spPr>
+        <p:style>
+          <a:lnRef idx="1">
+            <a:schemeClr val="accent1"/>
+          </a:lnRef>
+          <a:fillRef idx="3">
+            <a:schemeClr val="accent1"/>
+          </a:fillRef>
+          <a:effectRef idx="2">
+            <a:schemeClr val="accent1"/>
+          </a:effectRef>
+          <a:fontRef idx="minor">
+            <a:schemeClr val="lt1"/>
+          </a:fontRef>
+        </p:style>
+        <p:txBody>
+          <a:bodyPr rtlCol="0" anchor="ctr"/>
+          <a:lstStyle/>
+          <a:p>
+            <a:pPr algn="ctr"/>
+          </a:p>
+        </p:txBody>
+      </p:sp>
+      <p:sp>
+        <p:nvSpPr>
+          <p:cNvPr id="3" name="Rectangle 2"/>
+          <p:cNvSpPr/>
+          <p:nvPr/>
+        </p:nvSpPr>
+        <p:spPr>
+          <a:xfrm>
+            <a:off x="0" y="3200400"/>
+            <a:ext cx="12191695" cy="38100"/>
+          </a:xfrm>
+          <a:prstGeom prst="rect">
+            <a:avLst/>
+          </a:prstGeom>
+          <a:solidFill>
+            <a:srgbClr val="D40511"/>
+          </a:solidFill>
+          <a:ln>
+            <a:noFill/>
+          </a:ln>
+          <a:effectLst/>
+        </p:spPr>
+        <p:style>
+          <a:lnRef idx="1">
+            <a:schemeClr val="accent1"/>
+          </a:lnRef>
+          <a:fillRef idx="3">
+            <a:schemeClr val="accent1"/>
+          </a:fillRef>
+          <a:effectRef idx="2">
+            <a:schemeClr val="accent1"/>
+          </a:effectRef>
+          <a:fontRef idx="minor">
+            <a:schemeClr val="lt1"/>
+          </a:fontRef>
+        </p:style>
+        <p:txBody>
+          <a:bodyPr rtlCol="0" anchor="ctr"/>
+          <a:lstStyle/>
+          <a:p>
+            <a:pPr algn="ctr"/>
+          </a:p>
+        </p:txBody>
+      </p:sp>
+      <p:sp>
+        <p:nvSpPr>
+          <p:cNvPr id="4" name="TextBox 3"/>
+          <p:cNvSpPr txBox="1"/>
+          <p:nvPr/>
+        </p:nvSpPr>
+        <p:spPr>
+          <a:xfrm>
+            <a:off x="731520" y="2286000"/>
+            <a:ext cx="10698480" cy="914400"/>
+          </a:xfrm>
+          <a:prstGeom prst="rect">
+            <a:avLst/>
+          </a:prstGeom>
+          <a:noFill/>
+        </p:spPr>
+        <p:txBody>
+          <a:bodyPr wrap="square" anchor="b" lIns="0" rIns="0" tIns="0" bIns="0">
+            <a:spAutoFit/>
+          </a:bodyPr>
+          <a:lstStyle/>
+          <a:p>
+            <a:pPr algn="l">
+              <a:spcAft>
+                <a:spcPts val="600"/>
+              </a:spcAft>
+            </a:pPr>
+            <a:r>
+              <a:rPr sz="4000" b="1" i="0">
+                <a:solidFill>
+                  <a:srgbClr val="1A1D21"/>
+                </a:solidFill>
+                <a:latin typeface="Calibri"/>
+              </a:rPr>
+              <a:t>Thank you</a:t>
+            </a:r>
+          </a:p>
+        </p:txBody>
+      </p:sp>
+      <p:sp>
+        <p:nvSpPr>
+          <p:cNvPr id="5" name="TextBox 4"/>
+          <p:cNvSpPr txBox="1"/>
+          <p:nvPr/>
+        </p:nvSpPr>
+        <p:spPr>
+          <a:xfrm>
+            <a:off x="731520" y="3429000"/>
+            <a:ext cx="10698480" cy="1097280"/>
+          </a:xfrm>
+          <a:prstGeom prst="rect">
+            <a:avLst/>
+          </a:prstGeom>
+          <a:noFill/>
+        </p:spPr>
+        <p:txBody>
+          <a:bodyPr wrap="square" anchor="t" lIns="0" rIns="0" tIns="0" bIns="0">
+            <a:spAutoFit/>
+          </a:bodyPr>
+          <a:lstStyle/>
+          <a:p>
+            <a:pPr algn="l">
+              <a:spcAft>
+                <a:spcPts val="300"/>
+              </a:spcAft>
+            </a:pPr>
+            <a:r>
+              <a:rPr sz="1800" b="1" i="0">
+                <a:solidFill>
+                  <a:srgbClr val="1A1D21"/>
+                </a:solidFill>
+                <a:latin typeface="Calibri"/>
+              </a:rPr>
+              <a:t>Jean Kadadihi</a:t>
+            </a:r>
+          </a:p>
+          <a:p>
+            <a:pPr algn="l">
+              <a:spcAft>
+                <a:spcPts val="200"/>
+              </a:spcAft>
+            </a:pPr>
+            <a:r>
+              <a:rPr sz="1350" b="0" i="0">
+                <a:solidFill>
+                  <a:srgbClr val="5B6470"/>
+                </a:solidFill>
+                <a:latin typeface="Calibri"/>
+              </a:rPr>
+              <a:t>Finance Intern, Controlling  ·  DHL Express Americas, Key Account Desk (AMKAD)</a:t>
+            </a:r>
+          </a:p>
+          <a:p>
+            <a:pPr algn="l">
+              <a:spcAft>
+                <a:spcPts val="600"/>
+              </a:spcAft>
+            </a:pPr>
+            <a:r>
+              <a:rPr sz="1350" b="0" i="1">
+                <a:solidFill>
+                  <a:srgbClr val="A5040D"/>
+                </a:solidFill>
+                <a:latin typeface="Calibri"/>
+              </a:rPr>
+              <a:t>I would be happy to answer any questions.</a:t>
+            </a:r>
+          </a:p>
+        </p:txBody>
+      </p:sp>
+      <p:sp>
+        <p:nvSpPr>
+          <p:cNvPr id="6" name="Rounded Rectangle 5"/>
+          <p:cNvSpPr/>
+          <p:nvPr/>
+        </p:nvSpPr>
+        <p:spPr>
+          <a:xfrm>
+            <a:off x="9966960" y="548640"/>
+            <a:ext cx="1737360" cy="685800"/>
+          </a:xfrm>
+          <a:prstGeom prst="roundRect">
+            <a:avLst>
+              <a:gd name="adj" fmla="val 8000"/>
+            </a:avLst>
+          </a:prstGeom>
+          <a:solidFill>
+            <a:srgbClr val="FFFFFF"/>
+          </a:solidFill>
+          <a:ln w="9525">
+            <a:solidFill>
+              <a:srgbClr val="8A837B"/>
+            </a:solidFill>
+            <a:prstDash val="dash"/>
+          </a:ln>
+          <a:effectLst/>
+        </p:spPr>
+        <p:style>
+          <a:lnRef idx="1">
+            <a:schemeClr val="accent1"/>
+          </a:lnRef>
+          <a:fillRef idx="3">
+            <a:schemeClr val="accent1"/>
+          </a:fillRef>
+          <a:effectRef idx="2">
+            <a:schemeClr val="accent1"/>
+          </a:effectRef>
+          <a:fontRef idx="minor">
+            <a:schemeClr val="lt1"/>
+          </a:fontRef>
+        </p:style>
+        <p:txBody>
+          <a:bodyPr rtlCol="0" anchor="ctr"/>
+          <a:lstStyle/>
+          <a:p>
+            <a:pPr algn="ctr"/>
+          </a:p>
+        </p:txBody>
+      </p:sp>
+      <p:sp>
+        <p:nvSpPr>
+          <p:cNvPr id="7" name="TextBox 6"/>
+          <p:cNvSpPr txBox="1"/>
+          <p:nvPr/>
+        </p:nvSpPr>
+        <p:spPr>
+          <a:xfrm>
+            <a:off x="9966960" y="548640"/>
+            <a:ext cx="1737360" cy="685800"/>
+          </a:xfrm>
+          <a:prstGeom prst="rect">
+            <a:avLst/>
+          </a:prstGeom>
+          <a:noFill/>
+        </p:spPr>
+        <p:txBody>
+          <a:bodyPr wrap="square" anchor="ctr" lIns="0" rIns="0" tIns="0" bIns="0">
+            <a:spAutoFit/>
+          </a:bodyPr>
+          <a:lstStyle/>
+          <a:p>
+            <a:pPr algn="ctr">
+              <a:spcAft>
+                <a:spcPts val="600"/>
+              </a:spcAft>
+            </a:pPr>
+            <a:r>
+              <a:rPr sz="900" b="0" i="1">
+                <a:solidFill>
+                  <a:srgbClr val="8A837B"/>
+                </a:solidFill>
+                <a:latin typeface="Calibri"/>
+              </a:rPr>
+              <a:t>paste DHL logo</a:t>
             </a:r>
           </a:p>
         </p:txBody>

</xml_diff>

<commit_message>
Update impact model for 12 weekly SOAs at 30 min
SOA now 12/week at 30 min = 6 hrs/wk (was 6 SOAs at 30-60 min). Recomputed
combined to ~8.5-9 hrs/wk, ~36-38 hrs/mo, ~425-445 hrs/yr (~11 work-weeks),
and updated the headline stats, current-state strip, table, and assumptions.
SOA pillar slide updated to 12 SOAs with generic customer wording pending
the confirmed breakdown.
</commit_message>
<xml_diff>
--- a/docs/AMKAD_Internship_Presentation.pptx
+++ b/docs/AMKAD_Internship_Presentation.pptx
@@ -3738,7 +3738,7 @@
                 </a:solidFill>
                 <a:latin typeface="Calibri"/>
               </a:rPr>
-              <a:t>•  Automated 6 recurring weekly Statements of Account: Arrow Electronics across 5 countries, and Baker Hughes.</a:t>
+              <a:t>•  Automated 12 recurring weekly Statements of Account across multiple customers and countries.</a:t>
             </a:r>
           </a:p>
           <a:p>
@@ -3873,7 +3873,7 @@
                 </a:solidFill>
                 <a:latin typeface="Calibri"/>
               </a:rPr>
-              <a:t>To be clear on scope: two customers are live today, six SOAs a week, on a framework built so more can be added over time. The reusable engine is the part that is done.</a:t>
+              <a:t>12 SOAs a week are live today, on a framework built so more can be added over time. The reusable engine is the part that is done.</a:t>
             </a:r>
           </a:p>
         </p:txBody>
@@ -4266,7 +4266,7 @@
                 </a:solidFill>
                 <a:latin typeface="Calibri"/>
               </a:rPr>
-              <a:t>Live today:   ✓ Dashboard in production    ✓ Daily pipeline running    ✓ 6 weekly SOAs automated    ✓ Framework ready for more customers</a:t>
+              <a:t>Live today:   ✓ Dashboard in production    ✓ Daily pipeline running    ✓ 12 weekly SOAs automated    ✓ Framework ready for more customers</a:t>
             </a:r>
           </a:p>
         </p:txBody>
@@ -4955,7 +4955,7 @@
                 </a:solidFill>
                 <a:latin typeface="Calibri"/>
               </a:rPr>
-              <a:t>SOA automation  (6 SOAs × 30–60 min)</a:t>
+              <a:t>SOA automation  (12 SOAs × 30 min)</a:t>
             </a:r>
           </a:p>
         </p:txBody>
@@ -4994,7 +4994,7 @@
                 </a:solidFill>
                 <a:latin typeface="Calibri"/>
               </a:rPr>
-              <a:t>3–6 hrs</a:t>
+              <a:t>6 hrs</a:t>
             </a:r>
           </a:p>
         </p:txBody>
@@ -5033,7 +5033,7 @@
                 </a:solidFill>
                 <a:latin typeface="Calibri"/>
               </a:rPr>
-              <a:t>13–26 hrs</a:t>
+              <a:t>~26 hrs</a:t>
             </a:r>
           </a:p>
         </p:txBody>
@@ -5072,7 +5072,7 @@
                 </a:solidFill>
                 <a:latin typeface="Calibri"/>
               </a:rPr>
-              <a:t>150–300 hrs</a:t>
+              <a:t>~300 hrs</a:t>
             </a:r>
           </a:p>
         </p:txBody>
@@ -5240,7 +5240,7 @@
                 </a:solidFill>
                 <a:latin typeface="Calibri"/>
               </a:rPr>
-              <a:t>~5.5–9 hrs</a:t>
+              <a:t>~8.5–9 hrs</a:t>
             </a:r>
           </a:p>
         </p:txBody>
@@ -5279,7 +5279,7 @@
                 </a:solidFill>
                 <a:latin typeface="Calibri"/>
               </a:rPr>
-              <a:t>~24–38 hrs</a:t>
+              <a:t>~36–38 hrs</a:t>
             </a:r>
           </a:p>
         </p:txBody>
@@ -5318,7 +5318,7 @@
                 </a:solidFill>
                 <a:latin typeface="Calibri"/>
               </a:rPr>
-              <a:t>~275–445 hrs</a:t>
+              <a:t>~425–445 hrs</a:t>
             </a:r>
           </a:p>
         </p:txBody>
@@ -5357,7 +5357,7 @@
                 </a:solidFill>
                 <a:latin typeface="Calibri"/>
               </a:rPr>
-              <a:t>That comes to roughly 7 to 11 full work-weeks of time given back to the team each year.</a:t>
+              <a:t>That comes to roughly 11 full work-weeks of time given back to the team each year.</a:t>
             </a:r>
           </a:p>
           <a:p>
@@ -5373,7 +5373,7 @@
                 </a:solidFill>
                 <a:latin typeface="Calibri"/>
               </a:rPr>
-              <a:t>The assumptions are kept conservative on purpose: 5 business days a week, SOAs at 30 to 60 minutes each, 6 a week. The figures leave out error-correction, rework, and analysis time, so the real number is likely higher.</a:t>
+              <a:t>The assumptions are kept conservative on purpose: 5 business days a week, 12 SOAs a week at about 30 minutes each. The figures leave out error-correction, rework, and analysis time, so the real number is likely higher.</a:t>
             </a:r>
           </a:p>
         </p:txBody>
@@ -10760,7 +10760,7 @@
                 </a:solidFill>
                 <a:latin typeface="Calibri"/>
               </a:rPr>
-              <a:t>~275 hrs</a:t>
+              <a:t>~425 hrs</a:t>
             </a:r>
           </a:p>
           <a:p>
@@ -10776,7 +10776,7 @@
                 </a:solidFill>
                 <a:latin typeface="Calibri"/>
               </a:rPr>
-              <a:t>of team time given back each year, and likely more. A conservative estimate.</a:t>
+              <a:t>of team time given back each year, up to ~445. A conservative estimate.</a:t>
             </a:r>
           </a:p>
         </p:txBody>
@@ -10907,7 +10907,7 @@
                 </a:solidFill>
                 <a:latin typeface="Calibri"/>
               </a:rPr>
-              <a:t>6 / week</a:t>
+              <a:t>12 / week</a:t>
             </a:r>
           </a:p>
           <a:p>
@@ -10923,7 +10923,7 @@
                 </a:solidFill>
                 <a:latin typeface="Calibri"/>
               </a:rPr>
-              <a:t>statements now generated and emailed automatically (Arrow ×5, Baker ×1)</a:t>
+              <a:t>statements now generated and emailed automatically each week</a:t>
             </a:r>
           </a:p>
         </p:txBody>
@@ -11109,7 +11109,7 @@
                 </a:solidFill>
                 <a:latin typeface="Calibri"/>
               </a:rPr>
-              <a:t>That is roughly 7 to 11 full work-weeks a year that collectors can spend on collections instead of manual reporting.</a:t>
+              <a:t>That is roughly 11 full work-weeks a year that collectors can spend on collections instead of manual reporting.</a:t>
             </a:r>
           </a:p>
         </p:txBody>

</xml_diff>